<commit_message>
Release OneSlide v1.2.2 with native Sankey ribbons
</commit_message>
<xml_diff>
--- a/builder/assets/reference-pages/sankey-flow.pptx
+++ b/builder/assets/reference-pages/sankey-flow.pptx
@@ -2,13 +2,13 @@
 <file path=ppt/presentation.xml><?xml version="1.0" encoding="utf-8"?>
 <p:presentation xmlns:p="http://schemas.openxmlformats.org/presentationml/2006/main">
   <p:sldMasterIdLst>
-    <p:sldMasterId xmlns:r="http://schemas.openxmlformats.org/officeDocument/2006/relationships" id="2147483648" r:id="Rcd1b086813a74b64"/>
+    <p:sldMasterId xmlns:r="http://schemas.openxmlformats.org/officeDocument/2006/relationships" id="2147483648" r:id="R91d0fde551984408"/>
   </p:sldMasterIdLst>
   <p:notesMasterIdLst>
-    <p:notesMasterId xmlns:r="http://schemas.openxmlformats.org/officeDocument/2006/relationships" r:id="Rc7e695b74f5d4b9f"/>
+    <p:notesMasterId xmlns:r="http://schemas.openxmlformats.org/officeDocument/2006/relationships" r:id="R489413f83a014811"/>
   </p:notesMasterIdLst>
   <p:sldIdLst>
-    <p:sldId xmlns:r="http://schemas.openxmlformats.org/officeDocument/2006/relationships" id="256" r:id="R27f29d2600e648ae"/>
+    <p:sldId xmlns:r="http://schemas.openxmlformats.org/officeDocument/2006/relationships" id="256" r:id="Rdb47e794b5ed47b9"/>
   </p:sldIdLst>
   <p:sldSz cx="12192000" cy="6858000"/>
   <p:notesSz cx="6858000" cy="9144000"/>
@@ -506,7 +506,7 @@
   </p:cSld>
   <p:clrMap bg1="lt1" tx1="dk1" bg2="lt2" tx2="dk2" accent1="accent1" accent2="accent2" accent3="accent3" accent4="accent4" accent5="accent5" accent6="accent6" hlink="hlink" folHlink="folHlink"/>
   <p:sldLayoutIdLst>
-    <p:sldLayoutId xmlns:r="http://schemas.openxmlformats.org/officeDocument/2006/relationships" id="2147483649" r:id="Rb4fc4b0d8ee4419d"/>
+    <p:sldLayoutId xmlns:r="http://schemas.openxmlformats.org/officeDocument/2006/relationships" id="2147483649" r:id="R2b26e173adc44d89"/>
   </p:sldLayoutIdLst>
   <p:txStyles>
     <p:titleStyle>
@@ -1054,10 +1054,10 @@
       </p:grpSpPr>
       <p:sp>
         <p:nvSpPr>
-          <p:cNvPr id="40" name="page-title">
-            <a:extLst xmlns:a="http://schemas.openxmlformats.org/drawingml/2006/main">
-              <a:ext uri="{FF2B5EF4-FFF2-40B4-BE49-F238E27FC236}">
-                <a16:creationId xmlns:a16="http://schemas.microsoft.com/office/drawing/2014/main" id="{8A56D510-BA34-4F4C-8F4E-268CA9BA2493}"/>
+          <p:cNvPr id="60" name="page-title">
+            <a:extLst xmlns:a="http://schemas.openxmlformats.org/drawingml/2006/main">
+              <a:ext uri="{FF2B5EF4-FFF2-40B4-BE49-F238E27FC236}">
+                <a16:creationId xmlns:a16="http://schemas.microsoft.com/office/drawing/2014/main" id="{771E7B9C-2812-405A-B51B-7A1E8FCFCEE7}"/>
               </a:ext>
             </a:extLst>
           </p:cNvPr>
@@ -1081,18 +1081,20 @@
           </a:ln>
         </p:spPr>
         <p:txBody>
-          <a:bodyPr xmlns:a="http://schemas.openxmlformats.org/drawingml/2006/main" anchor="ctr"/>
+          <a:bodyPr xmlns:a="http://schemas.openxmlformats.org/drawingml/2006/main" wrap="square" lIns="38100" tIns="19050" rIns="38100" bIns="19050" anchor="ctr">
+            <a:noAutofit/>
+          </a:bodyPr>
           <a:lstStyle xmlns:a="http://schemas.openxmlformats.org/drawingml/2006/main"/>
           <a:p xmlns:a="http://schemas.openxmlformats.org/drawingml/2006/main">
             <a:pPr algn="l">
-              <a:defRPr sz="2550" b="1">
+              <a:defRPr sz="2600" b="1">
                 <a:solidFill>
                   <a:srgbClr val="15375F"/>
                 </a:solidFill>
               </a:defRPr>
             </a:pPr>
             <a:r>
-              <a:rPr sz="2550" b="1">
+              <a:rPr sz="2600" b="1">
                 <a:solidFill>
                   <a:srgbClr val="15375F"/>
                 </a:solidFill>
@@ -1107,7 +1109,7 @@
           <p:cNvPr id="2" name="sankey-frame">
             <a:extLst xmlns:a="http://schemas.openxmlformats.org/drawingml/2006/main">
               <a:ext uri="{FF2B5EF4-FFF2-40B4-BE49-F238E27FC236}">
-                <a16:creationId xmlns:a16="http://schemas.microsoft.com/office/drawing/2014/main" id="{26AC0577-6428-4B54-AA35-14E353D25E37}"/>
+                <a16:creationId xmlns:a16="http://schemas.microsoft.com/office/drawing/2014/main" id="{10BB62A2-D855-41F7-87BD-211E543D2DFE}"/>
               </a:ext>
             </a:extLst>
           </p:cNvPr>
@@ -1121,10 +1123,8 @@
             <a:off x="514350" y="1257300"/>
             <a:ext cx="8096250" cy="4286250"/>
           </a:xfrm>
-          <a:prstGeom xmlns:a="http://schemas.openxmlformats.org/drawingml/2006/main" prst="roundRect">
-            <a:avLst>
-              <a:gd name="adj" fmla="val 1778"/>
-            </a:avLst>
+          <a:prstGeom xmlns:a="http://schemas.openxmlformats.org/drawingml/2006/main" prst="rect">
+            <a:avLst/>
           </a:prstGeom>
           <a:solidFill xmlns:a="http://schemas.openxmlformats.org/drawingml/2006/main">
             <a:srgbClr val="FFFFFF"/>
@@ -1139,68 +1139,877 @@
       </p:sp>
       <p:sp>
         <p:nvSpPr>
-          <p:cNvPr id="3" name="node-social">
-            <a:extLst xmlns:a="http://schemas.openxmlformats.org/drawingml/2006/main">
-              <a:ext uri="{FF2B5EF4-FFF2-40B4-BE49-F238E27FC236}">
-                <a16:creationId xmlns:a16="http://schemas.microsoft.com/office/drawing/2014/main" id="{9C25D862-4D63-4EF6-817C-24D88609F1D4}"/>
-              </a:ext>
-            </a:extLst>
-          </p:cNvPr>
-          <p:cNvSpPr>
-            <a:spLocks xmlns:a="http://schemas.openxmlformats.org/drawingml/2006/main" noGrp="1"/>
-          </p:cNvSpPr>
-          <p:nvPr/>
-        </p:nvSpPr>
-        <p:spPr>
-          <a:xfrm xmlns:a="http://schemas.openxmlformats.org/drawingml/2006/main">
-            <a:off x="838200" y="1714500"/>
-            <a:ext cx="1047750" cy="1866900"/>
-          </a:xfrm>
-          <a:prstGeom xmlns:a="http://schemas.openxmlformats.org/drawingml/2006/main" prst="rect">
-            <a:avLst/>
-          </a:prstGeom>
-          <a:solidFill xmlns:a="http://schemas.openxmlformats.org/drawingml/2006/main">
-            <a:srgbClr val="15375F"/>
-          </a:solidFill>
-          <a:ln xmlns:a="http://schemas.openxmlformats.org/drawingml/2006/main" w="9525">
-            <a:solidFill>
-              <a:srgbClr val="FFFFFF"/>
-            </a:solidFill>
+          <p:cNvPr id="3" name="sankey-ribbon-6-pass-preloss">
+            <a:extLst xmlns:a="http://schemas.openxmlformats.org/drawingml/2006/main">
+              <a:ext uri="{FF2B5EF4-FFF2-40B4-BE49-F238E27FC236}">
+                <a16:creationId xmlns:a16="http://schemas.microsoft.com/office/drawing/2014/main" id="{F5E68A0C-D588-4B95-9ADD-E6C4C601EC5D}"/>
+              </a:ext>
+            </a:extLst>
+          </p:cNvPr>
+          <p:cNvSpPr>
+            <a:spLocks xmlns:a="http://schemas.openxmlformats.org/drawingml/2006/main" noGrp="1"/>
+          </p:cNvSpPr>
+          <p:nvPr/>
+        </p:nvSpPr>
+        <p:spPr>
+          <a:xfrm xmlns:a="http://schemas.openxmlformats.org/drawingml/2006/main">
+            <a:off x="3695700" y="2594610"/>
+            <a:ext cx="1733550" cy="1497965"/>
+          </a:xfrm>
+          <a:custGeom xmlns:a="http://schemas.openxmlformats.org/drawingml/2006/main">
+            <a:pathLst>
+              <a:path w="1733550" h="1497965">
+                <a:moveTo>
+                  <a:pt x="0" y="0"/>
+                </a:moveTo>
+                <a:cubicBezTo>
+                  <a:pt x="797433" y="0"/>
+                  <a:pt x="936117" y="66675"/>
+                  <a:pt x="1733550" y="66675"/>
+                </a:cubicBezTo>
+                <a:lnTo>
+                  <a:pt x="1733550" y="1497965"/>
+                </a:lnTo>
+                <a:cubicBezTo>
+                  <a:pt x="936117" y="1497965"/>
+                  <a:pt x="797433" y="1431290"/>
+                  <a:pt x="0" y="1431290"/>
+                </a:cubicBezTo>
+                <a:close/>
+              </a:path>
+            </a:pathLst>
+          </a:custGeom>
+          <a:gradFill xmlns:a="http://schemas.openxmlformats.org/drawingml/2006/main">
+            <a:gsLst>
+              <a:gs pos="0">
+                <a:srgbClr val="D96F16">
+                  <a:alpha val="78000"/>
+                </a:srgbClr>
+              </a:gs>
+              <a:gs pos="100000">
+                <a:srgbClr val="D96F16">
+                  <a:alpha val="62000"/>
+                </a:srgbClr>
+              </a:gs>
+            </a:gsLst>
+            <a:lin ang="0"/>
+          </a:gradFill>
+          <a:ln xmlns:a="http://schemas.openxmlformats.org/drawingml/2006/main" w="0">
+            <a:noFill/>
+            <a:prstDash val="solid"/>
+          </a:ln>
+        </p:spPr>
+      </p:sp>
+      <p:sp>
+        <p:nvSpPr>
+          <p:cNvPr id="4" name="sankey-ribbon-10-preloss-not_hired">
+            <a:extLst xmlns:a="http://schemas.openxmlformats.org/drawingml/2006/main">
+              <a:ext uri="{FF2B5EF4-FFF2-40B4-BE49-F238E27FC236}">
+                <a16:creationId xmlns:a16="http://schemas.microsoft.com/office/drawing/2014/main" id="{F7E788C0-F806-4275-AEC5-FDDEA458C433}"/>
+              </a:ext>
+            </a:extLst>
+          </p:cNvPr>
+          <p:cNvSpPr>
+            <a:spLocks xmlns:a="http://schemas.openxmlformats.org/drawingml/2006/main" noGrp="1"/>
+          </p:cNvSpPr>
+          <p:nvPr/>
+        </p:nvSpPr>
+        <p:spPr>
+          <a:xfrm xmlns:a="http://schemas.openxmlformats.org/drawingml/2006/main">
+            <a:off x="5619750" y="2661285"/>
+            <a:ext cx="1733550" cy="1497965"/>
+          </a:xfrm>
+          <a:custGeom xmlns:a="http://schemas.openxmlformats.org/drawingml/2006/main">
+            <a:pathLst>
+              <a:path w="1733550" h="1497965">
+                <a:moveTo>
+                  <a:pt x="0" y="0"/>
+                </a:moveTo>
+                <a:cubicBezTo>
+                  <a:pt x="797433" y="0"/>
+                  <a:pt x="936117" y="66675"/>
+                  <a:pt x="1733550" y="66675"/>
+                </a:cubicBezTo>
+                <a:lnTo>
+                  <a:pt x="1733550" y="1497965"/>
+                </a:lnTo>
+                <a:cubicBezTo>
+                  <a:pt x="936117" y="1497965"/>
+                  <a:pt x="797433" y="1431290"/>
+                  <a:pt x="0" y="1431290"/>
+                </a:cubicBezTo>
+                <a:close/>
+              </a:path>
+            </a:pathLst>
+          </a:custGeom>
+          <a:gradFill xmlns:a="http://schemas.openxmlformats.org/drawingml/2006/main">
+            <a:gsLst>
+              <a:gs pos="0">
+                <a:srgbClr val="D96F16">
+                  <a:alpha val="78000"/>
+                </a:srgbClr>
+              </a:gs>
+              <a:gs pos="100000">
+                <a:srgbClr val="D96F16">
+                  <a:alpha val="62000"/>
+                </a:srgbClr>
+              </a:gs>
+            </a:gsLst>
+            <a:lin ang="0"/>
+          </a:gradFill>
+          <a:ln xmlns:a="http://schemas.openxmlformats.org/drawingml/2006/main" w="0">
+            <a:noFill/>
+            <a:prstDash val="solid"/>
+          </a:ln>
+        </p:spPr>
+      </p:sp>
+      <p:sp>
+        <p:nvSpPr>
+          <p:cNvPr id="5" name="sankey-ribbon-1-social-pass">
+            <a:extLst xmlns:a="http://schemas.openxmlformats.org/drawingml/2006/main">
+              <a:ext uri="{FF2B5EF4-FFF2-40B4-BE49-F238E27FC236}">
+                <a16:creationId xmlns:a16="http://schemas.microsoft.com/office/drawing/2014/main" id="{B27BD370-598C-4177-9B60-06A1166274A9}"/>
+              </a:ext>
+            </a:extLst>
+          </p:cNvPr>
+          <p:cNvSpPr>
+            <a:spLocks xmlns:a="http://schemas.openxmlformats.org/drawingml/2006/main" noGrp="1"/>
+          </p:cNvSpPr>
+          <p:nvPr/>
+        </p:nvSpPr>
+        <p:spPr>
+          <a:xfrm xmlns:a="http://schemas.openxmlformats.org/drawingml/2006/main">
+            <a:off x="1771650" y="1981200"/>
+            <a:ext cx="1733550" cy="1201261"/>
+          </a:xfrm>
+          <a:custGeom xmlns:a="http://schemas.openxmlformats.org/drawingml/2006/main">
+            <a:pathLst>
+              <a:path w="1733550" h="1201261">
+                <a:moveTo>
+                  <a:pt x="0" y="0"/>
+                </a:moveTo>
+                <a:cubicBezTo>
+                  <a:pt x="797433" y="0"/>
+                  <a:pt x="936117" y="0"/>
+                  <a:pt x="1733550" y="0"/>
+                </a:cubicBezTo>
+                <a:lnTo>
+                  <a:pt x="1733550" y="1201261"/>
+                </a:lnTo>
+                <a:cubicBezTo>
+                  <a:pt x="936117" y="1201261"/>
+                  <a:pt x="797433" y="1201261"/>
+                  <a:pt x="0" y="1201261"/>
+                </a:cubicBezTo>
+                <a:close/>
+              </a:path>
+            </a:pathLst>
+          </a:custGeom>
+          <a:gradFill xmlns:a="http://schemas.openxmlformats.org/drawingml/2006/main">
+            <a:gsLst>
+              <a:gs pos="0">
+                <a:srgbClr val="1F66AD">
+                  <a:alpha val="78000"/>
+                </a:srgbClr>
+              </a:gs>
+              <a:gs pos="100000">
+                <a:srgbClr val="1F66AD">
+                  <a:alpha val="62000"/>
+                </a:srgbClr>
+              </a:gs>
+            </a:gsLst>
+            <a:lin ang="0"/>
+          </a:gradFill>
+          <a:ln xmlns:a="http://schemas.openxmlformats.org/drawingml/2006/main" w="0">
+            <a:noFill/>
+            <a:prstDash val="solid"/>
+          </a:ln>
+        </p:spPr>
+      </p:sp>
+      <p:sp>
+        <p:nvSpPr>
+          <p:cNvPr id="6" name="sankey-ribbon-7-reject-closed">
+            <a:extLst xmlns:a="http://schemas.openxmlformats.org/drawingml/2006/main">
+              <a:ext uri="{FF2B5EF4-FFF2-40B4-BE49-F238E27FC236}">
+                <a16:creationId xmlns:a16="http://schemas.microsoft.com/office/drawing/2014/main" id="{338473BF-355B-4AA2-92E1-5936F5174305}"/>
+              </a:ext>
+            </a:extLst>
+          </p:cNvPr>
+          <p:cNvSpPr>
+            <a:spLocks xmlns:a="http://schemas.openxmlformats.org/drawingml/2006/main" noGrp="1"/>
+          </p:cNvSpPr>
+          <p:nvPr/>
+        </p:nvSpPr>
+        <p:spPr>
+          <a:xfrm xmlns:a="http://schemas.openxmlformats.org/drawingml/2006/main">
+            <a:off x="3695700" y="4159250"/>
+            <a:ext cx="1733550" cy="1089025"/>
+          </a:xfrm>
+          <a:custGeom xmlns:a="http://schemas.openxmlformats.org/drawingml/2006/main">
+            <a:pathLst>
+              <a:path w="1733550" h="1089025">
+                <a:moveTo>
+                  <a:pt x="0" y="0"/>
+                </a:moveTo>
+                <a:cubicBezTo>
+                  <a:pt x="797433" y="0"/>
+                  <a:pt x="936117" y="66675"/>
+                  <a:pt x="1733550" y="66675"/>
+                </a:cubicBezTo>
+                <a:lnTo>
+                  <a:pt x="1733550" y="1089025"/>
+                </a:lnTo>
+                <a:cubicBezTo>
+                  <a:pt x="936117" y="1089025"/>
+                  <a:pt x="797433" y="1022350"/>
+                  <a:pt x="0" y="1022350"/>
+                </a:cubicBezTo>
+                <a:close/>
+              </a:path>
+            </a:pathLst>
+          </a:custGeom>
+          <a:gradFill xmlns:a="http://schemas.openxmlformats.org/drawingml/2006/main">
+            <a:gsLst>
+              <a:gs pos="0">
+                <a:srgbClr val="D96F16">
+                  <a:alpha val="78000"/>
+                </a:srgbClr>
+              </a:gs>
+              <a:gs pos="100000">
+                <a:srgbClr val="D96F16">
+                  <a:alpha val="62000"/>
+                </a:srgbClr>
+              </a:gs>
+            </a:gsLst>
+            <a:lin ang="0"/>
+          </a:gradFill>
+          <a:ln xmlns:a="http://schemas.openxmlformats.org/drawingml/2006/main" w="0">
+            <a:noFill/>
+            <a:prstDash val="solid"/>
+          </a:ln>
+        </p:spPr>
+      </p:sp>
+      <p:sp>
+        <p:nvSpPr>
+          <p:cNvPr id="7" name="sankey-ribbon-11-closed-screened_out">
+            <a:extLst xmlns:a="http://schemas.openxmlformats.org/drawingml/2006/main">
+              <a:ext uri="{FF2B5EF4-FFF2-40B4-BE49-F238E27FC236}">
+                <a16:creationId xmlns:a16="http://schemas.microsoft.com/office/drawing/2014/main" id="{F6760CB3-EF56-4E22-BAC8-D855BE7ED6E5}"/>
+              </a:ext>
+            </a:extLst>
+          </p:cNvPr>
+          <p:cNvSpPr>
+            <a:spLocks xmlns:a="http://schemas.openxmlformats.org/drawingml/2006/main" noGrp="1"/>
+          </p:cNvSpPr>
+          <p:nvPr/>
+        </p:nvSpPr>
+        <p:spPr>
+          <a:xfrm xmlns:a="http://schemas.openxmlformats.org/drawingml/2006/main">
+            <a:off x="5619750" y="4225925"/>
+            <a:ext cx="1733550" cy="1089025"/>
+          </a:xfrm>
+          <a:custGeom xmlns:a="http://schemas.openxmlformats.org/drawingml/2006/main">
+            <a:pathLst>
+              <a:path w="1733550" h="1089025">
+                <a:moveTo>
+                  <a:pt x="0" y="0"/>
+                </a:moveTo>
+                <a:cubicBezTo>
+                  <a:pt x="797433" y="0"/>
+                  <a:pt x="936117" y="66675"/>
+                  <a:pt x="1733550" y="66675"/>
+                </a:cubicBezTo>
+                <a:lnTo>
+                  <a:pt x="1733550" y="1089025"/>
+                </a:lnTo>
+                <a:cubicBezTo>
+                  <a:pt x="936117" y="1089025"/>
+                  <a:pt x="797433" y="1022350"/>
+                  <a:pt x="0" y="1022350"/>
+                </a:cubicBezTo>
+                <a:close/>
+              </a:path>
+            </a:pathLst>
+          </a:custGeom>
+          <a:gradFill xmlns:a="http://schemas.openxmlformats.org/drawingml/2006/main">
+            <a:gsLst>
+              <a:gs pos="0">
+                <a:srgbClr val="D96F16">
+                  <a:alpha val="78000"/>
+                </a:srgbClr>
+              </a:gs>
+              <a:gs pos="100000">
+                <a:srgbClr val="D96F16">
+                  <a:alpha val="62000"/>
+                </a:srgbClr>
+              </a:gs>
+            </a:gsLst>
+            <a:lin ang="0"/>
+          </a:gradFill>
+          <a:ln xmlns:a="http://schemas.openxmlformats.org/drawingml/2006/main" w="0">
+            <a:noFill/>
+            <a:prstDash val="solid"/>
+          </a:ln>
+        </p:spPr>
+      </p:sp>
+      <p:sp>
+        <p:nvSpPr>
+          <p:cNvPr id="8" name="sankey-ribbon-3-campus-pass">
+            <a:extLst xmlns:a="http://schemas.openxmlformats.org/drawingml/2006/main">
+              <a:ext uri="{FF2B5EF4-FFF2-40B4-BE49-F238E27FC236}">
+                <a16:creationId xmlns:a16="http://schemas.microsoft.com/office/drawing/2014/main" id="{9EA2863A-934F-4F51-A69F-9555CF9FB7E1}"/>
+              </a:ext>
+            </a:extLst>
+          </p:cNvPr>
+          <p:cNvSpPr>
+            <a:spLocks xmlns:a="http://schemas.openxmlformats.org/drawingml/2006/main" noGrp="1"/>
+          </p:cNvSpPr>
+          <p:nvPr/>
+        </p:nvSpPr>
+        <p:spPr>
+          <a:xfrm xmlns:a="http://schemas.openxmlformats.org/drawingml/2006/main">
+            <a:off x="1771650" y="3182461"/>
+            <a:ext cx="1733550" cy="1564640"/>
+          </a:xfrm>
+          <a:custGeom xmlns:a="http://schemas.openxmlformats.org/drawingml/2006/main">
+            <a:pathLst>
+              <a:path w="1733550" h="1564640">
+                <a:moveTo>
+                  <a:pt x="0" y="721201"/>
+                </a:moveTo>
+                <a:cubicBezTo>
+                  <a:pt x="797433" y="721201"/>
+                  <a:pt x="936117" y="0"/>
+                  <a:pt x="1733550" y="0"/>
+                </a:cubicBezTo>
+                <a:lnTo>
+                  <a:pt x="1733550" y="843439"/>
+                </a:lnTo>
+                <a:cubicBezTo>
+                  <a:pt x="936117" y="843439"/>
+                  <a:pt x="797433" y="1564640"/>
+                  <a:pt x="0" y="1564640"/>
+                </a:cubicBezTo>
+                <a:close/>
+              </a:path>
+            </a:pathLst>
+          </a:custGeom>
+          <a:gradFill xmlns:a="http://schemas.openxmlformats.org/drawingml/2006/main">
+            <a:gsLst>
+              <a:gs pos="0">
+                <a:srgbClr val="1F66AD">
+                  <a:alpha val="78000"/>
+                </a:srgbClr>
+              </a:gs>
+              <a:gs pos="100000">
+                <a:srgbClr val="1F66AD">
+                  <a:alpha val="62000"/>
+                </a:srgbClr>
+              </a:gs>
+            </a:gsLst>
+            <a:lin ang="0"/>
+          </a:gradFill>
+          <a:ln xmlns:a="http://schemas.openxmlformats.org/drawingml/2006/main" w="0">
+            <a:noFill/>
+            <a:prstDash val="solid"/>
+          </a:ln>
+        </p:spPr>
+      </p:sp>
+      <p:sp>
+        <p:nvSpPr>
+          <p:cNvPr id="9" name="sankey-ribbon-5-pass-hired">
+            <a:extLst xmlns:a="http://schemas.openxmlformats.org/drawingml/2006/main">
+              <a:ext uri="{FF2B5EF4-FFF2-40B4-BE49-F238E27FC236}">
+                <a16:creationId xmlns:a16="http://schemas.microsoft.com/office/drawing/2014/main" id="{42E35197-714B-4E78-B531-5C1B6A2B0DDF}"/>
+              </a:ext>
+            </a:extLst>
+          </p:cNvPr>
+          <p:cNvSpPr>
+            <a:spLocks xmlns:a="http://schemas.openxmlformats.org/drawingml/2006/main" noGrp="1"/>
+          </p:cNvSpPr>
+          <p:nvPr/>
+        </p:nvSpPr>
+        <p:spPr>
+          <a:xfrm xmlns:a="http://schemas.openxmlformats.org/drawingml/2006/main">
+            <a:off x="3695700" y="1914525"/>
+            <a:ext cx="1733550" cy="680085"/>
+          </a:xfrm>
+          <a:custGeom xmlns:a="http://schemas.openxmlformats.org/drawingml/2006/main">
+            <a:pathLst>
+              <a:path w="1733550" h="680085">
+                <a:moveTo>
+                  <a:pt x="0" y="66675"/>
+                </a:moveTo>
+                <a:cubicBezTo>
+                  <a:pt x="797433" y="66675"/>
+                  <a:pt x="936117" y="0"/>
+                  <a:pt x="1733550" y="0"/>
+                </a:cubicBezTo>
+                <a:lnTo>
+                  <a:pt x="1733550" y="613410"/>
+                </a:lnTo>
+                <a:cubicBezTo>
+                  <a:pt x="936117" y="613410"/>
+                  <a:pt x="797433" y="680085"/>
+                  <a:pt x="0" y="680085"/>
+                </a:cubicBezTo>
+                <a:close/>
+              </a:path>
+            </a:pathLst>
+          </a:custGeom>
+          <a:gradFill xmlns:a="http://schemas.openxmlformats.org/drawingml/2006/main">
+            <a:gsLst>
+              <a:gs pos="0">
+                <a:srgbClr val="1F66AD">
+                  <a:alpha val="78000"/>
+                </a:srgbClr>
+              </a:gs>
+              <a:gs pos="100000">
+                <a:srgbClr val="1F66AD">
+                  <a:alpha val="62000"/>
+                </a:srgbClr>
+              </a:gs>
+            </a:gsLst>
+            <a:lin ang="0"/>
+          </a:gradFill>
+          <a:ln xmlns:a="http://schemas.openxmlformats.org/drawingml/2006/main" w="0">
+            <a:noFill/>
+            <a:prstDash val="solid"/>
+          </a:ln>
+        </p:spPr>
+      </p:sp>
+      <p:sp>
+        <p:nvSpPr>
+          <p:cNvPr id="10" name="sankey-ribbon-2-social-reject">
+            <a:extLst xmlns:a="http://schemas.openxmlformats.org/drawingml/2006/main">
+              <a:ext uri="{FF2B5EF4-FFF2-40B4-BE49-F238E27FC236}">
+                <a16:creationId xmlns:a16="http://schemas.microsoft.com/office/drawing/2014/main" id="{7AD14179-C7CF-4EA9-8848-F7B51E4D3743}"/>
+              </a:ext>
+            </a:extLst>
+          </p:cNvPr>
+          <p:cNvSpPr>
+            <a:spLocks xmlns:a="http://schemas.openxmlformats.org/drawingml/2006/main" noGrp="1"/>
+          </p:cNvSpPr>
+          <p:nvPr/>
+        </p:nvSpPr>
+        <p:spPr>
+          <a:xfrm xmlns:a="http://schemas.openxmlformats.org/drawingml/2006/main">
+            <a:off x="1771650" y="3182461"/>
+            <a:ext cx="1733550" cy="1564640"/>
+          </a:xfrm>
+          <a:custGeom xmlns:a="http://schemas.openxmlformats.org/drawingml/2006/main">
+            <a:pathLst>
+              <a:path w="1733550" h="1564640">
+                <a:moveTo>
+                  <a:pt x="0" y="0"/>
+                </a:moveTo>
+                <a:cubicBezTo>
+                  <a:pt x="797433" y="0"/>
+                  <a:pt x="936117" y="976789"/>
+                  <a:pt x="1733550" y="976789"/>
+                </a:cubicBezTo>
+                <a:lnTo>
+                  <a:pt x="1733550" y="1564640"/>
+                </a:lnTo>
+                <a:cubicBezTo>
+                  <a:pt x="936117" y="1564640"/>
+                  <a:pt x="797433" y="587851"/>
+                  <a:pt x="0" y="587851"/>
+                </a:cubicBezTo>
+                <a:close/>
+              </a:path>
+            </a:pathLst>
+          </a:custGeom>
+          <a:gradFill xmlns:a="http://schemas.openxmlformats.org/drawingml/2006/main">
+            <a:gsLst>
+              <a:gs pos="0">
+                <a:srgbClr val="D96F16">
+                  <a:alpha val="78000"/>
+                </a:srgbClr>
+              </a:gs>
+              <a:gs pos="100000">
+                <a:srgbClr val="D96F16">
+                  <a:alpha val="62000"/>
+                </a:srgbClr>
+              </a:gs>
+            </a:gsLst>
+            <a:lin ang="0"/>
+          </a:gradFill>
+          <a:ln xmlns:a="http://schemas.openxmlformats.org/drawingml/2006/main" w="0">
+            <a:noFill/>
+            <a:prstDash val="solid"/>
+          </a:ln>
+        </p:spPr>
+      </p:sp>
+      <p:sp>
+        <p:nvSpPr>
+          <p:cNvPr id="11" name="sankey-ribbon-9-hired-turnover">
+            <a:extLst xmlns:a="http://schemas.openxmlformats.org/drawingml/2006/main">
+              <a:ext uri="{FF2B5EF4-FFF2-40B4-BE49-F238E27FC236}">
+                <a16:creationId xmlns:a16="http://schemas.microsoft.com/office/drawing/2014/main" id="{C01AEE00-78A8-47E3-A794-9A938DEE3F58}"/>
+              </a:ext>
+            </a:extLst>
+          </p:cNvPr>
+          <p:cNvSpPr>
+            <a:spLocks xmlns:a="http://schemas.openxmlformats.org/drawingml/2006/main" noGrp="1"/>
+          </p:cNvSpPr>
+          <p:nvPr/>
+        </p:nvSpPr>
+        <p:spPr>
+          <a:xfrm xmlns:a="http://schemas.openxmlformats.org/drawingml/2006/main">
+            <a:off x="5619750" y="2067878"/>
+            <a:ext cx="1733550" cy="526732"/>
+          </a:xfrm>
+          <a:custGeom xmlns:a="http://schemas.openxmlformats.org/drawingml/2006/main">
+            <a:pathLst>
+              <a:path w="1733550" h="526732">
+                <a:moveTo>
+                  <a:pt x="0" y="0"/>
+                </a:moveTo>
+                <a:cubicBezTo>
+                  <a:pt x="797433" y="0"/>
+                  <a:pt x="936117" y="66675"/>
+                  <a:pt x="1733550" y="66675"/>
+                </a:cubicBezTo>
+                <a:lnTo>
+                  <a:pt x="1733550" y="526732"/>
+                </a:lnTo>
+                <a:cubicBezTo>
+                  <a:pt x="936117" y="526732"/>
+                  <a:pt x="797433" y="460057"/>
+                  <a:pt x="0" y="460057"/>
+                </a:cubicBezTo>
+                <a:close/>
+              </a:path>
+            </a:pathLst>
+          </a:custGeom>
+          <a:gradFill xmlns:a="http://schemas.openxmlformats.org/drawingml/2006/main">
+            <a:gsLst>
+              <a:gs pos="0">
+                <a:srgbClr val="D96F16">
+                  <a:alpha val="78000"/>
+                </a:srgbClr>
+              </a:gs>
+              <a:gs pos="100000">
+                <a:srgbClr val="D96F16">
+                  <a:alpha val="62000"/>
+                </a:srgbClr>
+              </a:gs>
+            </a:gsLst>
+            <a:lin ang="0"/>
+          </a:gradFill>
+          <a:ln xmlns:a="http://schemas.openxmlformats.org/drawingml/2006/main" w="0">
+            <a:noFill/>
+            <a:prstDash val="solid"/>
+          </a:ln>
+        </p:spPr>
+      </p:sp>
+      <p:sp>
+        <p:nvSpPr>
+          <p:cNvPr id="12" name="sankey-ribbon-4-campus-reject">
+            <a:extLst xmlns:a="http://schemas.openxmlformats.org/drawingml/2006/main">
+              <a:ext uri="{FF2B5EF4-FFF2-40B4-BE49-F238E27FC236}">
+                <a16:creationId xmlns:a16="http://schemas.microsoft.com/office/drawing/2014/main" id="{66BB785B-20CC-4CA7-BBF8-8B566BB69FDF}"/>
+              </a:ext>
+            </a:extLst>
+          </p:cNvPr>
+          <p:cNvSpPr>
+            <a:spLocks xmlns:a="http://schemas.openxmlformats.org/drawingml/2006/main" noGrp="1"/>
+          </p:cNvSpPr>
+          <p:nvPr/>
+        </p:nvSpPr>
+        <p:spPr>
+          <a:xfrm xmlns:a="http://schemas.openxmlformats.org/drawingml/2006/main">
+            <a:off x="1771650" y="4747101"/>
+            <a:ext cx="1733550" cy="434499"/>
+          </a:xfrm>
+          <a:custGeom xmlns:a="http://schemas.openxmlformats.org/drawingml/2006/main">
+            <a:pathLst>
+              <a:path w="1733550" h="434499">
+                <a:moveTo>
+                  <a:pt x="0" y="0"/>
+                </a:moveTo>
+                <a:cubicBezTo>
+                  <a:pt x="797433" y="0"/>
+                  <a:pt x="936117" y="0"/>
+                  <a:pt x="1733550" y="0"/>
+                </a:cubicBezTo>
+                <a:lnTo>
+                  <a:pt x="1733550" y="434499"/>
+                </a:lnTo>
+                <a:cubicBezTo>
+                  <a:pt x="936117" y="434499"/>
+                  <a:pt x="797433" y="434499"/>
+                  <a:pt x="0" y="434499"/>
+                </a:cubicBezTo>
+                <a:close/>
+              </a:path>
+            </a:pathLst>
+          </a:custGeom>
+          <a:gradFill xmlns:a="http://schemas.openxmlformats.org/drawingml/2006/main">
+            <a:gsLst>
+              <a:gs pos="0">
+                <a:srgbClr val="D96F16">
+                  <a:alpha val="78000"/>
+                </a:srgbClr>
+              </a:gs>
+              <a:gs pos="100000">
+                <a:srgbClr val="D96F16">
+                  <a:alpha val="62000"/>
+                </a:srgbClr>
+              </a:gs>
+            </a:gsLst>
+            <a:lin ang="0"/>
+          </a:gradFill>
+          <a:ln xmlns:a="http://schemas.openxmlformats.org/drawingml/2006/main" w="0">
+            <a:noFill/>
+            <a:prstDash val="solid"/>
+          </a:ln>
+        </p:spPr>
+      </p:sp>
+      <p:sp>
+        <p:nvSpPr>
+          <p:cNvPr id="13" name="sankey-ribbon-8-hired-retained">
+            <a:extLst xmlns:a="http://schemas.openxmlformats.org/drawingml/2006/main">
+              <a:ext uri="{FF2B5EF4-FFF2-40B4-BE49-F238E27FC236}">
+                <a16:creationId xmlns:a16="http://schemas.microsoft.com/office/drawing/2014/main" id="{0D5295CE-1B87-4701-82FA-1D94BA55D257}"/>
+              </a:ext>
+            </a:extLst>
+          </p:cNvPr>
+          <p:cNvSpPr>
+            <a:spLocks xmlns:a="http://schemas.openxmlformats.org/drawingml/2006/main" noGrp="1"/>
+          </p:cNvSpPr>
+          <p:nvPr/>
+        </p:nvSpPr>
+        <p:spPr>
+          <a:xfrm xmlns:a="http://schemas.openxmlformats.org/drawingml/2006/main">
+            <a:off x="5619750" y="1847850"/>
+            <a:ext cx="1733550" cy="220027"/>
+          </a:xfrm>
+          <a:custGeom xmlns:a="http://schemas.openxmlformats.org/drawingml/2006/main">
+            <a:pathLst>
+              <a:path w="1733550" h="220027">
+                <a:moveTo>
+                  <a:pt x="0" y="66675"/>
+                </a:moveTo>
+                <a:cubicBezTo>
+                  <a:pt x="797433" y="66675"/>
+                  <a:pt x="936117" y="0"/>
+                  <a:pt x="1733550" y="0"/>
+                </a:cubicBezTo>
+                <a:lnTo>
+                  <a:pt x="1733550" y="153352"/>
+                </a:lnTo>
+                <a:cubicBezTo>
+                  <a:pt x="936117" y="153352"/>
+                  <a:pt x="797433" y="220027"/>
+                  <a:pt x="0" y="220027"/>
+                </a:cubicBezTo>
+                <a:close/>
+              </a:path>
+            </a:pathLst>
+          </a:custGeom>
+          <a:gradFill xmlns:a="http://schemas.openxmlformats.org/drawingml/2006/main">
+            <a:gsLst>
+              <a:gs pos="0">
+                <a:srgbClr val="1F66AD">
+                  <a:alpha val="78000"/>
+                </a:srgbClr>
+              </a:gs>
+              <a:gs pos="100000">
+                <a:srgbClr val="1F66AD">
+                  <a:alpha val="62000"/>
+                </a:srgbClr>
+              </a:gs>
+            </a:gsLst>
+            <a:lin ang="0"/>
+          </a:gradFill>
+          <a:ln xmlns:a="http://schemas.openxmlformats.org/drawingml/2006/main" w="0">
+            <a:noFill/>
+            <a:prstDash val="solid"/>
+          </a:ln>
+        </p:spPr>
+      </p:sp>
+      <p:sp>
+        <p:nvSpPr>
+          <p:cNvPr id="14" name="layer-1">
+            <a:extLst xmlns:a="http://schemas.openxmlformats.org/drawingml/2006/main">
+              <a:ext uri="{FF2B5EF4-FFF2-40B4-BE49-F238E27FC236}">
+                <a16:creationId xmlns:a16="http://schemas.microsoft.com/office/drawing/2014/main" id="{561E97BF-E95A-457F-9456-D93051BF076C}"/>
+              </a:ext>
+            </a:extLst>
+          </p:cNvPr>
+          <p:cNvSpPr>
+            <a:spLocks xmlns:a="http://schemas.openxmlformats.org/drawingml/2006/main" noGrp="1"/>
+          </p:cNvSpPr>
+          <p:nvPr/>
+        </p:nvSpPr>
+        <p:spPr>
+          <a:xfrm xmlns:a="http://schemas.openxmlformats.org/drawingml/2006/main">
+            <a:off x="609600" y="1333500"/>
+            <a:ext cx="1838325" cy="438150"/>
+          </a:xfrm>
+          <a:prstGeom xmlns:a="http://schemas.openxmlformats.org/drawingml/2006/main" prst="rect">
+            <a:avLst/>
+          </a:prstGeom>
+          <a:noFill xmlns:a="http://schemas.openxmlformats.org/drawingml/2006/main"/>
+          <a:ln xmlns:a="http://schemas.openxmlformats.org/drawingml/2006/main" w="0">
+            <a:noFill/>
             <a:prstDash val="solid"/>
           </a:ln>
         </p:spPr>
         <p:txBody>
-          <a:bodyPr xmlns:a="http://schemas.openxmlformats.org/drawingml/2006/main" anchor="ctr"/>
+          <a:bodyPr xmlns:a="http://schemas.openxmlformats.org/drawingml/2006/main" wrap="square" lIns="38100" tIns="19050" rIns="38100" bIns="19050" anchor="ctr">
+            <a:noAutofit/>
+          </a:bodyPr>
           <a:lstStyle xmlns:a="http://schemas.openxmlformats.org/drawingml/2006/main"/>
           <a:p xmlns:a="http://schemas.openxmlformats.org/drawingml/2006/main">
             <a:pPr algn="ctr">
-              <a:defRPr sz="1600" b="1">
-                <a:solidFill>
-                  <a:srgbClr val="FFFFFF"/>
+              <a:defRPr sz="1200" b="1">
+                <a:solidFill>
+                  <a:srgbClr val="15375F"/>
                 </a:solidFill>
               </a:defRPr>
             </a:pPr>
             <a:r>
-              <a:rPr sz="1600" b="1">
-                <a:solidFill>
-                  <a:srgbClr val="FFFFFF"/>
+              <a:rPr sz="1200" b="1">
+                <a:solidFill>
+                  <a:srgbClr val="15375F"/>
+                </a:solidFill>
+              </a:rPr>
+              <a:t>来源渠道；1,200 人</a:t>
+            </a:r>
+          </a:p>
+        </p:txBody>
+      </p:sp>
+      <p:sp>
+        <p:nvSpPr>
+          <p:cNvPr id="15" name="node-social">
+            <a:extLst xmlns:a="http://schemas.openxmlformats.org/drawingml/2006/main">
+              <a:ext uri="{FF2B5EF4-FFF2-40B4-BE49-F238E27FC236}">
+                <a16:creationId xmlns:a16="http://schemas.microsoft.com/office/drawing/2014/main" id="{3F1815AF-EBA1-4B31-A3B1-FB26C847B2A8}"/>
+              </a:ext>
+            </a:extLst>
+          </p:cNvPr>
+          <p:cNvSpPr>
+            <a:spLocks xmlns:a="http://schemas.openxmlformats.org/drawingml/2006/main" noGrp="1"/>
+          </p:cNvSpPr>
+          <p:nvPr/>
+        </p:nvSpPr>
+        <p:spPr>
+          <a:xfrm xmlns:a="http://schemas.openxmlformats.org/drawingml/2006/main">
+            <a:off x="1581150" y="1981200"/>
+            <a:ext cx="190500" cy="1789112"/>
+          </a:xfrm>
+          <a:prstGeom xmlns:a="http://schemas.openxmlformats.org/drawingml/2006/main" prst="rect">
+            <a:avLst/>
+          </a:prstGeom>
+          <a:solidFill xmlns:a="http://schemas.openxmlformats.org/drawingml/2006/main">
+            <a:srgbClr val="1F66AD"/>
+          </a:solidFill>
+          <a:ln xmlns:a="http://schemas.openxmlformats.org/drawingml/2006/main" w="0">
+            <a:noFill/>
+            <a:prstDash val="solid"/>
+          </a:ln>
+        </p:spPr>
+      </p:sp>
+      <p:sp>
+        <p:nvSpPr>
+          <p:cNvPr id="16" name="node-label-social">
+            <a:extLst xmlns:a="http://schemas.openxmlformats.org/drawingml/2006/main">
+              <a:ext uri="{FF2B5EF4-FFF2-40B4-BE49-F238E27FC236}">
+                <a16:creationId xmlns:a16="http://schemas.microsoft.com/office/drawing/2014/main" id="{9AF02BA2-5DDC-4809-859A-FF06F7FAC70D}"/>
+              </a:ext>
+            </a:extLst>
+          </p:cNvPr>
+          <p:cNvSpPr>
+            <a:spLocks xmlns:a="http://schemas.openxmlformats.org/drawingml/2006/main" noGrp="1"/>
+          </p:cNvSpPr>
+          <p:nvPr/>
+        </p:nvSpPr>
+        <p:spPr>
+          <a:xfrm xmlns:a="http://schemas.openxmlformats.org/drawingml/2006/main">
+            <a:off x="628650" y="2666206"/>
+            <a:ext cx="857250" cy="247650"/>
+          </a:xfrm>
+          <a:prstGeom xmlns:a="http://schemas.openxmlformats.org/drawingml/2006/main" prst="rect">
+            <a:avLst/>
+          </a:prstGeom>
+          <a:noFill xmlns:a="http://schemas.openxmlformats.org/drawingml/2006/main"/>
+          <a:ln xmlns:a="http://schemas.openxmlformats.org/drawingml/2006/main" w="0">
+            <a:noFill/>
+            <a:prstDash val="solid"/>
+          </a:ln>
+        </p:spPr>
+        <p:txBody>
+          <a:bodyPr xmlns:a="http://schemas.openxmlformats.org/drawingml/2006/main" wrap="square" lIns="38100" tIns="19050" rIns="38100" bIns="19050" anchor="ctr">
+            <a:noAutofit/>
+          </a:bodyPr>
+          <a:lstStyle xmlns:a="http://schemas.openxmlformats.org/drawingml/2006/main"/>
+          <a:p xmlns:a="http://schemas.openxmlformats.org/drawingml/2006/main">
+            <a:pPr algn="r">
+              <a:defRPr sz="1200" b="1">
+                <a:solidFill>
+                  <a:srgbClr val="172033"/>
+                </a:solidFill>
+              </a:defRPr>
+            </a:pPr>
+            <a:r>
+              <a:rPr sz="1200" b="1">
+                <a:solidFill>
+                  <a:srgbClr val="172033"/>
                 </a:solidFill>
               </a:rPr>
               <a:t>社会招聘</a:t>
             </a:r>
           </a:p>
+        </p:txBody>
+      </p:sp>
+      <p:sp>
+        <p:nvSpPr>
+          <p:cNvPr id="17" name="node-value-social">
+            <a:extLst xmlns:a="http://schemas.openxmlformats.org/drawingml/2006/main">
+              <a:ext uri="{FF2B5EF4-FFF2-40B4-BE49-F238E27FC236}">
+                <a16:creationId xmlns:a16="http://schemas.microsoft.com/office/drawing/2014/main" id="{45F1E2FA-082D-4B35-A96B-5D30F564F2C1}"/>
+              </a:ext>
+            </a:extLst>
+          </p:cNvPr>
+          <p:cNvSpPr>
+            <a:spLocks xmlns:a="http://schemas.openxmlformats.org/drawingml/2006/main" noGrp="1"/>
+          </p:cNvSpPr>
+          <p:nvPr/>
+        </p:nvSpPr>
+        <p:spPr>
+          <a:xfrm xmlns:a="http://schemas.openxmlformats.org/drawingml/2006/main">
+            <a:off x="628650" y="2923381"/>
+            <a:ext cx="857250" cy="171450"/>
+          </a:xfrm>
+          <a:prstGeom xmlns:a="http://schemas.openxmlformats.org/drawingml/2006/main" prst="rect">
+            <a:avLst/>
+          </a:prstGeom>
+          <a:noFill xmlns:a="http://schemas.openxmlformats.org/drawingml/2006/main"/>
+          <a:ln xmlns:a="http://schemas.openxmlformats.org/drawingml/2006/main" w="0">
+            <a:noFill/>
+            <a:prstDash val="solid"/>
+          </a:ln>
+        </p:spPr>
+        <p:txBody>
+          <a:bodyPr xmlns:a="http://schemas.openxmlformats.org/drawingml/2006/main" wrap="none" lIns="38100" tIns="19050" rIns="38100" bIns="19050" anchor="ctr">
+            <a:noAutofit/>
+          </a:bodyPr>
+          <a:lstStyle xmlns:a="http://schemas.openxmlformats.org/drawingml/2006/main"/>
           <a:p xmlns:a="http://schemas.openxmlformats.org/drawingml/2006/main">
-            <a:pPr algn="ctr">
-              <a:defRPr sz="1600" b="1">
-                <a:solidFill>
-                  <a:srgbClr val="FFFFFF"/>
+            <a:pPr algn="r">
+              <a:defRPr sz="1200" b="0">
+                <a:solidFill>
+                  <a:srgbClr val="697386"/>
                 </a:solidFill>
               </a:defRPr>
             </a:pPr>
             <a:r>
-              <a:rPr sz="1600" b="1">
-                <a:solidFill>
-                  <a:srgbClr val="FFFFFF"/>
+              <a:rPr sz="1200" b="0">
+                <a:solidFill>
+                  <a:srgbClr val="697386"/>
                 </a:solidFill>
               </a:rPr>
               <a:t>700</a:t>
@@ -1210,68 +2019,132 @@
       </p:sp>
       <p:sp>
         <p:nvSpPr>
-          <p:cNvPr id="4" name="node-campus">
-            <a:extLst xmlns:a="http://schemas.openxmlformats.org/drawingml/2006/main">
-              <a:ext uri="{FF2B5EF4-FFF2-40B4-BE49-F238E27FC236}">
-                <a16:creationId xmlns:a16="http://schemas.microsoft.com/office/drawing/2014/main" id="{6FF8F007-3524-42DE-8024-D11A749C7DEE}"/>
-              </a:ext>
-            </a:extLst>
-          </p:cNvPr>
-          <p:cNvSpPr>
-            <a:spLocks xmlns:a="http://schemas.openxmlformats.org/drawingml/2006/main" noGrp="1"/>
-          </p:cNvSpPr>
-          <p:nvPr/>
-        </p:nvSpPr>
-        <p:spPr>
-          <a:xfrm xmlns:a="http://schemas.openxmlformats.org/drawingml/2006/main">
-            <a:off x="838200" y="3790950"/>
-            <a:ext cx="1047750" cy="1333500"/>
+          <p:cNvPr id="18" name="node-campus">
+            <a:extLst xmlns:a="http://schemas.openxmlformats.org/drawingml/2006/main">
+              <a:ext uri="{FF2B5EF4-FFF2-40B4-BE49-F238E27FC236}">
+                <a16:creationId xmlns:a16="http://schemas.microsoft.com/office/drawing/2014/main" id="{75E7A1B4-375E-4376-9285-34DCF1035C82}"/>
+              </a:ext>
+            </a:extLst>
+          </p:cNvPr>
+          <p:cNvSpPr>
+            <a:spLocks xmlns:a="http://schemas.openxmlformats.org/drawingml/2006/main" noGrp="1"/>
+          </p:cNvSpPr>
+          <p:nvPr/>
+        </p:nvSpPr>
+        <p:spPr>
+          <a:xfrm xmlns:a="http://schemas.openxmlformats.org/drawingml/2006/main">
+            <a:off x="1581150" y="3903663"/>
+            <a:ext cx="190500" cy="1277938"/>
           </a:xfrm>
           <a:prstGeom xmlns:a="http://schemas.openxmlformats.org/drawingml/2006/main" prst="rect">
             <a:avLst/>
           </a:prstGeom>
           <a:solidFill xmlns:a="http://schemas.openxmlformats.org/drawingml/2006/main">
-            <a:srgbClr val="15375F"/>
-          </a:solidFill>
-          <a:ln xmlns:a="http://schemas.openxmlformats.org/drawingml/2006/main" w="9525">
-            <a:solidFill>
-              <a:srgbClr val="FFFFFF"/>
-            </a:solidFill>
+            <a:srgbClr val="1F66AD"/>
+          </a:solidFill>
+          <a:ln xmlns:a="http://schemas.openxmlformats.org/drawingml/2006/main" w="0">
+            <a:noFill/>
+            <a:prstDash val="solid"/>
+          </a:ln>
+        </p:spPr>
+      </p:sp>
+      <p:sp>
+        <p:nvSpPr>
+          <p:cNvPr id="19" name="node-label-campus">
+            <a:extLst xmlns:a="http://schemas.openxmlformats.org/drawingml/2006/main">
+              <a:ext uri="{FF2B5EF4-FFF2-40B4-BE49-F238E27FC236}">
+                <a16:creationId xmlns:a16="http://schemas.microsoft.com/office/drawing/2014/main" id="{1E2C8B97-9B38-4F72-88C6-58E6F56A2DE2}"/>
+              </a:ext>
+            </a:extLst>
+          </p:cNvPr>
+          <p:cNvSpPr>
+            <a:spLocks xmlns:a="http://schemas.openxmlformats.org/drawingml/2006/main" noGrp="1"/>
+          </p:cNvSpPr>
+          <p:nvPr/>
+        </p:nvSpPr>
+        <p:spPr>
+          <a:xfrm xmlns:a="http://schemas.openxmlformats.org/drawingml/2006/main">
+            <a:off x="628650" y="4333081"/>
+            <a:ext cx="857250" cy="247650"/>
+          </a:xfrm>
+          <a:prstGeom xmlns:a="http://schemas.openxmlformats.org/drawingml/2006/main" prst="rect">
+            <a:avLst/>
+          </a:prstGeom>
+          <a:noFill xmlns:a="http://schemas.openxmlformats.org/drawingml/2006/main"/>
+          <a:ln xmlns:a="http://schemas.openxmlformats.org/drawingml/2006/main" w="0">
+            <a:noFill/>
             <a:prstDash val="solid"/>
           </a:ln>
         </p:spPr>
         <p:txBody>
-          <a:bodyPr xmlns:a="http://schemas.openxmlformats.org/drawingml/2006/main" anchor="ctr"/>
+          <a:bodyPr xmlns:a="http://schemas.openxmlformats.org/drawingml/2006/main" wrap="square" lIns="38100" tIns="19050" rIns="38100" bIns="19050" anchor="ctr">
+            <a:noAutofit/>
+          </a:bodyPr>
           <a:lstStyle xmlns:a="http://schemas.openxmlformats.org/drawingml/2006/main"/>
           <a:p xmlns:a="http://schemas.openxmlformats.org/drawingml/2006/main">
-            <a:pPr algn="ctr">
-              <a:defRPr sz="1600" b="1">
-                <a:solidFill>
-                  <a:srgbClr val="FFFFFF"/>
+            <a:pPr algn="r">
+              <a:defRPr sz="1200" b="1">
+                <a:solidFill>
+                  <a:srgbClr val="172033"/>
                 </a:solidFill>
               </a:defRPr>
             </a:pPr>
             <a:r>
-              <a:rPr sz="1600" b="1">
-                <a:solidFill>
-                  <a:srgbClr val="FFFFFF"/>
+              <a:rPr sz="1200" b="1">
+                <a:solidFill>
+                  <a:srgbClr val="172033"/>
                 </a:solidFill>
               </a:rPr>
               <a:t>校园招聘</a:t>
             </a:r>
           </a:p>
+        </p:txBody>
+      </p:sp>
+      <p:sp>
+        <p:nvSpPr>
+          <p:cNvPr id="20" name="node-value-campus">
+            <a:extLst xmlns:a="http://schemas.openxmlformats.org/drawingml/2006/main">
+              <a:ext uri="{FF2B5EF4-FFF2-40B4-BE49-F238E27FC236}">
+                <a16:creationId xmlns:a16="http://schemas.microsoft.com/office/drawing/2014/main" id="{B8D77D90-F594-4B09-8E06-B9F6DE60CBF8}"/>
+              </a:ext>
+            </a:extLst>
+          </p:cNvPr>
+          <p:cNvSpPr>
+            <a:spLocks xmlns:a="http://schemas.openxmlformats.org/drawingml/2006/main" noGrp="1"/>
+          </p:cNvSpPr>
+          <p:nvPr/>
+        </p:nvSpPr>
+        <p:spPr>
+          <a:xfrm xmlns:a="http://schemas.openxmlformats.org/drawingml/2006/main">
+            <a:off x="628650" y="4590256"/>
+            <a:ext cx="857250" cy="171450"/>
+          </a:xfrm>
+          <a:prstGeom xmlns:a="http://schemas.openxmlformats.org/drawingml/2006/main" prst="rect">
+            <a:avLst/>
+          </a:prstGeom>
+          <a:noFill xmlns:a="http://schemas.openxmlformats.org/drawingml/2006/main"/>
+          <a:ln xmlns:a="http://schemas.openxmlformats.org/drawingml/2006/main" w="0">
+            <a:noFill/>
+            <a:prstDash val="solid"/>
+          </a:ln>
+        </p:spPr>
+        <p:txBody>
+          <a:bodyPr xmlns:a="http://schemas.openxmlformats.org/drawingml/2006/main" wrap="none" lIns="38100" tIns="19050" rIns="38100" bIns="19050" anchor="ctr">
+            <a:noAutofit/>
+          </a:bodyPr>
+          <a:lstStyle xmlns:a="http://schemas.openxmlformats.org/drawingml/2006/main"/>
           <a:p xmlns:a="http://schemas.openxmlformats.org/drawingml/2006/main">
-            <a:pPr algn="ctr">
-              <a:defRPr sz="1600" b="1">
-                <a:solidFill>
-                  <a:srgbClr val="FFFFFF"/>
+            <a:pPr algn="r">
+              <a:defRPr sz="1200" b="0">
+                <a:solidFill>
+                  <a:srgbClr val="697386"/>
                 </a:solidFill>
               </a:defRPr>
             </a:pPr>
             <a:r>
-              <a:rPr sz="1600" b="1">
-                <a:solidFill>
-                  <a:srgbClr val="FFFFFF"/>
+              <a:rPr sz="1200" b="0">
+                <a:solidFill>
+                  <a:srgbClr val="697386"/>
                 </a:solidFill>
               </a:rPr>
               <a:t>500</a:t>
@@ -1281,22 +2154,22 @@
       </p:sp>
       <p:sp>
         <p:nvSpPr>
-          <p:cNvPr id="5" name="layer-1">
-            <a:extLst xmlns:a="http://schemas.openxmlformats.org/drawingml/2006/main">
-              <a:ext uri="{FF2B5EF4-FFF2-40B4-BE49-F238E27FC236}">
-                <a16:creationId xmlns:a16="http://schemas.microsoft.com/office/drawing/2014/main" id="{2B3D7BB7-4FD3-4505-A500-63B2A439E7D4}"/>
-              </a:ext>
-            </a:extLst>
-          </p:cNvPr>
-          <p:cNvSpPr>
-            <a:spLocks xmlns:a="http://schemas.openxmlformats.org/drawingml/2006/main" noGrp="1"/>
-          </p:cNvSpPr>
-          <p:nvPr/>
-        </p:nvSpPr>
-        <p:spPr>
-          <a:xfrm xmlns:a="http://schemas.openxmlformats.org/drawingml/2006/main">
-            <a:off x="838200" y="1352550"/>
-            <a:ext cx="1047750" cy="266700"/>
+          <p:cNvPr id="21" name="layer-2">
+            <a:extLst xmlns:a="http://schemas.openxmlformats.org/drawingml/2006/main">
+              <a:ext uri="{FF2B5EF4-FFF2-40B4-BE49-F238E27FC236}">
+                <a16:creationId xmlns:a16="http://schemas.microsoft.com/office/drawing/2014/main" id="{E51F0286-9F6D-48E7-8426-EE5C7AD07375}"/>
+              </a:ext>
+            </a:extLst>
+          </p:cNvPr>
+          <p:cNvSpPr>
+            <a:spLocks xmlns:a="http://schemas.openxmlformats.org/drawingml/2006/main" noGrp="1"/>
+          </p:cNvSpPr>
+          <p:nvPr/>
+        </p:nvSpPr>
+        <p:spPr>
+          <a:xfrm xmlns:a="http://schemas.openxmlformats.org/drawingml/2006/main">
+            <a:off x="2638425" y="1333500"/>
+            <a:ext cx="1924050" cy="438150"/>
           </a:xfrm>
           <a:prstGeom xmlns:a="http://schemas.openxmlformats.org/drawingml/2006/main" prst="rect">
             <a:avLst/>
@@ -1308,91 +2181,157 @@
           </a:ln>
         </p:spPr>
         <p:txBody>
-          <a:bodyPr xmlns:a="http://schemas.openxmlformats.org/drawingml/2006/main" anchor="ctr"/>
+          <a:bodyPr xmlns:a="http://schemas.openxmlformats.org/drawingml/2006/main" wrap="square" lIns="38100" tIns="19050" rIns="38100" bIns="19050" anchor="ctr">
+            <a:noAutofit/>
+          </a:bodyPr>
           <a:lstStyle xmlns:a="http://schemas.openxmlformats.org/drawingml/2006/main"/>
           <a:p xmlns:a="http://schemas.openxmlformats.org/drawingml/2006/main">
             <a:pPr algn="ctr">
-              <a:defRPr sz="1600" b="1">
+              <a:defRPr sz="1200" b="1">
                 <a:solidFill>
                   <a:srgbClr val="15375F"/>
                 </a:solidFill>
               </a:defRPr>
             </a:pPr>
             <a:r>
-              <a:rPr sz="1600" b="1">
+              <a:rPr sz="1200" b="1">
                 <a:solidFill>
                   <a:srgbClr val="15375F"/>
                 </a:solidFill>
               </a:rPr>
-              <a:t>来源渠道｜1,200 人</a:t>
+              <a:t>筛选结果；通过率 67%</a:t>
             </a:r>
           </a:p>
         </p:txBody>
       </p:sp>
       <p:sp>
         <p:nvSpPr>
-          <p:cNvPr id="6" name="node-pass">
-            <a:extLst xmlns:a="http://schemas.openxmlformats.org/drawingml/2006/main">
-              <a:ext uri="{FF2B5EF4-FFF2-40B4-BE49-F238E27FC236}">
-                <a16:creationId xmlns:a16="http://schemas.microsoft.com/office/drawing/2014/main" id="{89B8DCB0-52DB-4996-B4EA-E9106B766099}"/>
-              </a:ext>
-            </a:extLst>
-          </p:cNvPr>
-          <p:cNvSpPr>
-            <a:spLocks xmlns:a="http://schemas.openxmlformats.org/drawingml/2006/main" noGrp="1"/>
-          </p:cNvSpPr>
-          <p:nvPr/>
-        </p:nvSpPr>
-        <p:spPr>
-          <a:xfrm xmlns:a="http://schemas.openxmlformats.org/drawingml/2006/main">
-            <a:off x="2971800" y="1714500"/>
-            <a:ext cx="1047750" cy="2133600"/>
+          <p:cNvPr id="22" name="node-pass">
+            <a:extLst xmlns:a="http://schemas.openxmlformats.org/drawingml/2006/main">
+              <a:ext uri="{FF2B5EF4-FFF2-40B4-BE49-F238E27FC236}">
+                <a16:creationId xmlns:a16="http://schemas.microsoft.com/office/drawing/2014/main" id="{35B9BE32-3F7D-428B-8C94-E1CD7DFC3D5B}"/>
+              </a:ext>
+            </a:extLst>
+          </p:cNvPr>
+          <p:cNvSpPr>
+            <a:spLocks xmlns:a="http://schemas.openxmlformats.org/drawingml/2006/main" noGrp="1"/>
+          </p:cNvSpPr>
+          <p:nvPr/>
+        </p:nvSpPr>
+        <p:spPr>
+          <a:xfrm xmlns:a="http://schemas.openxmlformats.org/drawingml/2006/main">
+            <a:off x="3505200" y="1981200"/>
+            <a:ext cx="190500" cy="2044700"/>
           </a:xfrm>
           <a:prstGeom xmlns:a="http://schemas.openxmlformats.org/drawingml/2006/main" prst="rect">
             <a:avLst/>
           </a:prstGeom>
           <a:solidFill xmlns:a="http://schemas.openxmlformats.org/drawingml/2006/main">
-            <a:srgbClr val="15375F"/>
-          </a:solidFill>
-          <a:ln xmlns:a="http://schemas.openxmlformats.org/drawingml/2006/main" w="9525">
-            <a:solidFill>
-              <a:srgbClr val="FFFFFF"/>
-            </a:solidFill>
+            <a:srgbClr val="1F66AD"/>
+          </a:solidFill>
+          <a:ln xmlns:a="http://schemas.openxmlformats.org/drawingml/2006/main" w="0">
+            <a:noFill/>
+            <a:prstDash val="solid"/>
+          </a:ln>
+        </p:spPr>
+      </p:sp>
+      <p:sp>
+        <p:nvSpPr>
+          <p:cNvPr id="23" name="node-label-pass">
+            <a:extLst xmlns:a="http://schemas.openxmlformats.org/drawingml/2006/main">
+              <a:ext uri="{FF2B5EF4-FFF2-40B4-BE49-F238E27FC236}">
+                <a16:creationId xmlns:a16="http://schemas.microsoft.com/office/drawing/2014/main" id="{B1092917-34AF-49DB-997D-F4BA2FC432FF}"/>
+              </a:ext>
+            </a:extLst>
+          </p:cNvPr>
+          <p:cNvSpPr>
+            <a:spLocks xmlns:a="http://schemas.openxmlformats.org/drawingml/2006/main" noGrp="1"/>
+          </p:cNvSpPr>
+          <p:nvPr/>
+        </p:nvSpPr>
+        <p:spPr>
+          <a:xfrm xmlns:a="http://schemas.openxmlformats.org/drawingml/2006/main">
+            <a:off x="3790950" y="2794000"/>
+            <a:ext cx="1028700" cy="247650"/>
+          </a:xfrm>
+          <a:prstGeom xmlns:a="http://schemas.openxmlformats.org/drawingml/2006/main" prst="rect">
+            <a:avLst/>
+          </a:prstGeom>
+          <a:noFill xmlns:a="http://schemas.openxmlformats.org/drawingml/2006/main"/>
+          <a:ln xmlns:a="http://schemas.openxmlformats.org/drawingml/2006/main" w="0">
+            <a:noFill/>
             <a:prstDash val="solid"/>
           </a:ln>
         </p:spPr>
         <p:txBody>
-          <a:bodyPr xmlns:a="http://schemas.openxmlformats.org/drawingml/2006/main" anchor="ctr"/>
+          <a:bodyPr xmlns:a="http://schemas.openxmlformats.org/drawingml/2006/main" wrap="square" lIns="38100" tIns="19050" rIns="38100" bIns="19050" anchor="ctr">
+            <a:noAutofit/>
+          </a:bodyPr>
           <a:lstStyle xmlns:a="http://schemas.openxmlformats.org/drawingml/2006/main"/>
           <a:p xmlns:a="http://schemas.openxmlformats.org/drawingml/2006/main">
-            <a:pPr algn="ctr">
-              <a:defRPr sz="1600" b="1">
-                <a:solidFill>
-                  <a:srgbClr val="FFFFFF"/>
+            <a:pPr algn="l">
+              <a:defRPr sz="1200" b="1">
+                <a:solidFill>
+                  <a:srgbClr val="172033"/>
                 </a:solidFill>
               </a:defRPr>
             </a:pPr>
             <a:r>
-              <a:rPr sz="1600" b="1">
-                <a:solidFill>
-                  <a:srgbClr val="FFFFFF"/>
+              <a:rPr sz="1200" b="1">
+                <a:solidFill>
+                  <a:srgbClr val="172033"/>
                 </a:solidFill>
               </a:rPr>
               <a:t>筛选通过</a:t>
             </a:r>
           </a:p>
+        </p:txBody>
+      </p:sp>
+      <p:sp>
+        <p:nvSpPr>
+          <p:cNvPr id="24" name="node-value-pass">
+            <a:extLst xmlns:a="http://schemas.openxmlformats.org/drawingml/2006/main">
+              <a:ext uri="{FF2B5EF4-FFF2-40B4-BE49-F238E27FC236}">
+                <a16:creationId xmlns:a16="http://schemas.microsoft.com/office/drawing/2014/main" id="{9C9630AC-D426-4FE8-BFBE-0A42EBD8F2E5}"/>
+              </a:ext>
+            </a:extLst>
+          </p:cNvPr>
+          <p:cNvSpPr>
+            <a:spLocks xmlns:a="http://schemas.openxmlformats.org/drawingml/2006/main" noGrp="1"/>
+          </p:cNvSpPr>
+          <p:nvPr/>
+        </p:nvSpPr>
+        <p:spPr>
+          <a:xfrm xmlns:a="http://schemas.openxmlformats.org/drawingml/2006/main">
+            <a:off x="3790950" y="3051175"/>
+            <a:ext cx="1028700" cy="171450"/>
+          </a:xfrm>
+          <a:prstGeom xmlns:a="http://schemas.openxmlformats.org/drawingml/2006/main" prst="rect">
+            <a:avLst/>
+          </a:prstGeom>
+          <a:noFill xmlns:a="http://schemas.openxmlformats.org/drawingml/2006/main"/>
+          <a:ln xmlns:a="http://schemas.openxmlformats.org/drawingml/2006/main" w="0">
+            <a:noFill/>
+            <a:prstDash val="solid"/>
+          </a:ln>
+        </p:spPr>
+        <p:txBody>
+          <a:bodyPr xmlns:a="http://schemas.openxmlformats.org/drawingml/2006/main" wrap="none" lIns="38100" tIns="19050" rIns="38100" bIns="19050" anchor="ctr">
+            <a:noAutofit/>
+          </a:bodyPr>
+          <a:lstStyle xmlns:a="http://schemas.openxmlformats.org/drawingml/2006/main"/>
           <a:p xmlns:a="http://schemas.openxmlformats.org/drawingml/2006/main">
-            <a:pPr algn="ctr">
-              <a:defRPr sz="1600" b="1">
-                <a:solidFill>
-                  <a:srgbClr val="FFFFFF"/>
+            <a:pPr algn="l">
+              <a:defRPr sz="1200" b="0">
+                <a:solidFill>
+                  <a:srgbClr val="697386"/>
                 </a:solidFill>
               </a:defRPr>
             </a:pPr>
             <a:r>
-              <a:rPr sz="1600" b="1">
-                <a:solidFill>
-                  <a:srgbClr val="FFFFFF"/>
+              <a:rPr sz="1200" b="0">
+                <a:solidFill>
+                  <a:srgbClr val="697386"/>
                 </a:solidFill>
               </a:rPr>
               <a:t>800</a:t>
@@ -1402,68 +2341,132 @@
       </p:sp>
       <p:sp>
         <p:nvSpPr>
-          <p:cNvPr id="7" name="node-reject">
-            <a:extLst xmlns:a="http://schemas.openxmlformats.org/drawingml/2006/main">
-              <a:ext uri="{FF2B5EF4-FFF2-40B4-BE49-F238E27FC236}">
-                <a16:creationId xmlns:a16="http://schemas.microsoft.com/office/drawing/2014/main" id="{7B45675F-8040-4AFE-B399-D16E2A7C4C5A}"/>
-              </a:ext>
-            </a:extLst>
-          </p:cNvPr>
-          <p:cNvSpPr>
-            <a:spLocks xmlns:a="http://schemas.openxmlformats.org/drawingml/2006/main" noGrp="1"/>
-          </p:cNvSpPr>
-          <p:nvPr/>
-        </p:nvSpPr>
-        <p:spPr>
-          <a:xfrm xmlns:a="http://schemas.openxmlformats.org/drawingml/2006/main">
-            <a:off x="2971800" y="4057650"/>
-            <a:ext cx="1047750" cy="1066800"/>
+          <p:cNvPr id="25" name="node-reject">
+            <a:extLst xmlns:a="http://schemas.openxmlformats.org/drawingml/2006/main">
+              <a:ext uri="{FF2B5EF4-FFF2-40B4-BE49-F238E27FC236}">
+                <a16:creationId xmlns:a16="http://schemas.microsoft.com/office/drawing/2014/main" id="{07CD32E4-A33C-4D76-B958-0435547C3A4E}"/>
+              </a:ext>
+            </a:extLst>
+          </p:cNvPr>
+          <p:cNvSpPr>
+            <a:spLocks xmlns:a="http://schemas.openxmlformats.org/drawingml/2006/main" noGrp="1"/>
+          </p:cNvSpPr>
+          <p:nvPr/>
+        </p:nvSpPr>
+        <p:spPr>
+          <a:xfrm xmlns:a="http://schemas.openxmlformats.org/drawingml/2006/main">
+            <a:off x="3505200" y="4159250"/>
+            <a:ext cx="190500" cy="1022350"/>
           </a:xfrm>
           <a:prstGeom xmlns:a="http://schemas.openxmlformats.org/drawingml/2006/main" prst="rect">
             <a:avLst/>
           </a:prstGeom>
           <a:solidFill xmlns:a="http://schemas.openxmlformats.org/drawingml/2006/main">
-            <a:srgbClr val="15375F"/>
-          </a:solidFill>
-          <a:ln xmlns:a="http://schemas.openxmlformats.org/drawingml/2006/main" w="9525">
-            <a:solidFill>
-              <a:srgbClr val="FFFFFF"/>
-            </a:solidFill>
+            <a:srgbClr val="D96F16"/>
+          </a:solidFill>
+          <a:ln xmlns:a="http://schemas.openxmlformats.org/drawingml/2006/main" w="0">
+            <a:noFill/>
+            <a:prstDash val="solid"/>
+          </a:ln>
+        </p:spPr>
+      </p:sp>
+      <p:sp>
+        <p:nvSpPr>
+          <p:cNvPr id="26" name="node-label-reject">
+            <a:extLst xmlns:a="http://schemas.openxmlformats.org/drawingml/2006/main">
+              <a:ext uri="{FF2B5EF4-FFF2-40B4-BE49-F238E27FC236}">
+                <a16:creationId xmlns:a16="http://schemas.microsoft.com/office/drawing/2014/main" id="{440C89F2-75B2-4A12-AF3B-DC011EAA7B44}"/>
+              </a:ext>
+            </a:extLst>
+          </p:cNvPr>
+          <p:cNvSpPr>
+            <a:spLocks xmlns:a="http://schemas.openxmlformats.org/drawingml/2006/main" noGrp="1"/>
+          </p:cNvSpPr>
+          <p:nvPr/>
+        </p:nvSpPr>
+        <p:spPr>
+          <a:xfrm xmlns:a="http://schemas.openxmlformats.org/drawingml/2006/main">
+            <a:off x="3790950" y="4460875"/>
+            <a:ext cx="1028700" cy="247650"/>
+          </a:xfrm>
+          <a:prstGeom xmlns:a="http://schemas.openxmlformats.org/drawingml/2006/main" prst="rect">
+            <a:avLst/>
+          </a:prstGeom>
+          <a:noFill xmlns:a="http://schemas.openxmlformats.org/drawingml/2006/main"/>
+          <a:ln xmlns:a="http://schemas.openxmlformats.org/drawingml/2006/main" w="0">
+            <a:noFill/>
             <a:prstDash val="solid"/>
           </a:ln>
         </p:spPr>
         <p:txBody>
-          <a:bodyPr xmlns:a="http://schemas.openxmlformats.org/drawingml/2006/main" anchor="ctr"/>
+          <a:bodyPr xmlns:a="http://schemas.openxmlformats.org/drawingml/2006/main" wrap="square" lIns="38100" tIns="19050" rIns="38100" bIns="19050" anchor="ctr">
+            <a:noAutofit/>
+          </a:bodyPr>
           <a:lstStyle xmlns:a="http://schemas.openxmlformats.org/drawingml/2006/main"/>
           <a:p xmlns:a="http://schemas.openxmlformats.org/drawingml/2006/main">
-            <a:pPr algn="ctr">
-              <a:defRPr sz="1600" b="1">
-                <a:solidFill>
-                  <a:srgbClr val="FFFFFF"/>
+            <a:pPr algn="l">
+              <a:defRPr sz="1200" b="1">
+                <a:solidFill>
+                  <a:srgbClr val="172033"/>
                 </a:solidFill>
               </a:defRPr>
             </a:pPr>
             <a:r>
-              <a:rPr sz="1600" b="1">
-                <a:solidFill>
-                  <a:srgbClr val="FFFFFF"/>
+              <a:rPr sz="1200" b="1">
+                <a:solidFill>
+                  <a:srgbClr val="172033"/>
                 </a:solidFill>
               </a:rPr>
               <a:t>筛选损耗</a:t>
             </a:r>
           </a:p>
+        </p:txBody>
+      </p:sp>
+      <p:sp>
+        <p:nvSpPr>
+          <p:cNvPr id="27" name="node-value-reject">
+            <a:extLst xmlns:a="http://schemas.openxmlformats.org/drawingml/2006/main">
+              <a:ext uri="{FF2B5EF4-FFF2-40B4-BE49-F238E27FC236}">
+                <a16:creationId xmlns:a16="http://schemas.microsoft.com/office/drawing/2014/main" id="{0F848510-818C-4390-BD08-4FCF58112639}"/>
+              </a:ext>
+            </a:extLst>
+          </p:cNvPr>
+          <p:cNvSpPr>
+            <a:spLocks xmlns:a="http://schemas.openxmlformats.org/drawingml/2006/main" noGrp="1"/>
+          </p:cNvSpPr>
+          <p:nvPr/>
+        </p:nvSpPr>
+        <p:spPr>
+          <a:xfrm xmlns:a="http://schemas.openxmlformats.org/drawingml/2006/main">
+            <a:off x="3790950" y="4718050"/>
+            <a:ext cx="1028700" cy="171450"/>
+          </a:xfrm>
+          <a:prstGeom xmlns:a="http://schemas.openxmlformats.org/drawingml/2006/main" prst="rect">
+            <a:avLst/>
+          </a:prstGeom>
+          <a:noFill xmlns:a="http://schemas.openxmlformats.org/drawingml/2006/main"/>
+          <a:ln xmlns:a="http://schemas.openxmlformats.org/drawingml/2006/main" w="0">
+            <a:noFill/>
+            <a:prstDash val="solid"/>
+          </a:ln>
+        </p:spPr>
+        <p:txBody>
+          <a:bodyPr xmlns:a="http://schemas.openxmlformats.org/drawingml/2006/main" wrap="none" lIns="38100" tIns="19050" rIns="38100" bIns="19050" anchor="ctr">
+            <a:noAutofit/>
+          </a:bodyPr>
+          <a:lstStyle xmlns:a="http://schemas.openxmlformats.org/drawingml/2006/main"/>
           <a:p xmlns:a="http://schemas.openxmlformats.org/drawingml/2006/main">
-            <a:pPr algn="ctr">
-              <a:defRPr sz="1600" b="1">
-                <a:solidFill>
-                  <a:srgbClr val="FFFFFF"/>
+            <a:pPr algn="l">
+              <a:defRPr sz="1200" b="0">
+                <a:solidFill>
+                  <a:srgbClr val="697386"/>
                 </a:solidFill>
               </a:defRPr>
             </a:pPr>
             <a:r>
-              <a:rPr sz="1600" b="1">
-                <a:solidFill>
-                  <a:srgbClr val="FFFFFF"/>
+              <a:rPr sz="1200" b="0">
+                <a:solidFill>
+                  <a:srgbClr val="697386"/>
                 </a:solidFill>
               </a:rPr>
               <a:t>400</a:t>
@@ -1473,22 +2476,22 @@
       </p:sp>
       <p:sp>
         <p:nvSpPr>
-          <p:cNvPr id="8" name="layer-2">
-            <a:extLst xmlns:a="http://schemas.openxmlformats.org/drawingml/2006/main">
-              <a:ext uri="{FF2B5EF4-FFF2-40B4-BE49-F238E27FC236}">
-                <a16:creationId xmlns:a16="http://schemas.microsoft.com/office/drawing/2014/main" id="{588433BF-A601-4019-88CC-18E70809B7F6}"/>
-              </a:ext>
-            </a:extLst>
-          </p:cNvPr>
-          <p:cNvSpPr>
-            <a:spLocks xmlns:a="http://schemas.openxmlformats.org/drawingml/2006/main" noGrp="1"/>
-          </p:cNvSpPr>
-          <p:nvPr/>
-        </p:nvSpPr>
-        <p:spPr>
-          <a:xfrm xmlns:a="http://schemas.openxmlformats.org/drawingml/2006/main">
-            <a:off x="2971800" y="1352550"/>
-            <a:ext cx="1047750" cy="266700"/>
+          <p:cNvPr id="28" name="layer-3">
+            <a:extLst xmlns:a="http://schemas.openxmlformats.org/drawingml/2006/main">
+              <a:ext uri="{FF2B5EF4-FFF2-40B4-BE49-F238E27FC236}">
+                <a16:creationId xmlns:a16="http://schemas.microsoft.com/office/drawing/2014/main" id="{D6367E38-A044-4828-AC8A-0AABA32BA688}"/>
+              </a:ext>
+            </a:extLst>
+          </p:cNvPr>
+          <p:cNvSpPr>
+            <a:spLocks xmlns:a="http://schemas.openxmlformats.org/drawingml/2006/main" noGrp="1"/>
+          </p:cNvSpPr>
+          <p:nvPr/>
+        </p:nvSpPr>
+        <p:spPr>
+          <a:xfrm xmlns:a="http://schemas.openxmlformats.org/drawingml/2006/main">
+            <a:off x="4562475" y="1333500"/>
+            <a:ext cx="1924050" cy="438150"/>
           </a:xfrm>
           <a:prstGeom xmlns:a="http://schemas.openxmlformats.org/drawingml/2006/main" prst="rect">
             <a:avLst/>
@@ -1500,91 +2503,157 @@
           </a:ln>
         </p:spPr>
         <p:txBody>
-          <a:bodyPr xmlns:a="http://schemas.openxmlformats.org/drawingml/2006/main" anchor="ctr"/>
+          <a:bodyPr xmlns:a="http://schemas.openxmlformats.org/drawingml/2006/main" wrap="square" lIns="38100" tIns="19050" rIns="38100" bIns="19050" anchor="ctr">
+            <a:noAutofit/>
+          </a:bodyPr>
           <a:lstStyle xmlns:a="http://schemas.openxmlformats.org/drawingml/2006/main"/>
           <a:p xmlns:a="http://schemas.openxmlformats.org/drawingml/2006/main">
             <a:pPr algn="ctr">
-              <a:defRPr sz="1600" b="1">
+              <a:defRPr sz="1200" b="1">
                 <a:solidFill>
                   <a:srgbClr val="15375F"/>
                 </a:solidFill>
               </a:defRPr>
             </a:pPr>
             <a:r>
-              <a:rPr sz="1600" b="1">
+              <a:rPr sz="1200" b="1">
                 <a:solidFill>
                   <a:srgbClr val="15375F"/>
                 </a:solidFill>
               </a:rPr>
-              <a:t>筛选结果｜通过率 67%</a:t>
+              <a:t>入职去向；入职率 20%</a:t>
             </a:r>
           </a:p>
         </p:txBody>
       </p:sp>
       <p:sp>
         <p:nvSpPr>
-          <p:cNvPr id="9" name="node-hired">
-            <a:extLst xmlns:a="http://schemas.openxmlformats.org/drawingml/2006/main">
-              <a:ext uri="{FF2B5EF4-FFF2-40B4-BE49-F238E27FC236}">
-                <a16:creationId xmlns:a16="http://schemas.microsoft.com/office/drawing/2014/main" id="{CD51F29A-B4CB-4467-847B-6783FC0D09E1}"/>
-              </a:ext>
-            </a:extLst>
-          </p:cNvPr>
-          <p:cNvSpPr>
-            <a:spLocks xmlns:a="http://schemas.openxmlformats.org/drawingml/2006/main" noGrp="1"/>
-          </p:cNvSpPr>
-          <p:nvPr/>
-        </p:nvSpPr>
-        <p:spPr>
-          <a:xfrm xmlns:a="http://schemas.openxmlformats.org/drawingml/2006/main">
-            <a:off x="5105400" y="1714500"/>
-            <a:ext cx="1047750" cy="598170"/>
+          <p:cNvPr id="29" name="node-hired">
+            <a:extLst xmlns:a="http://schemas.openxmlformats.org/drawingml/2006/main">
+              <a:ext uri="{FF2B5EF4-FFF2-40B4-BE49-F238E27FC236}">
+                <a16:creationId xmlns:a16="http://schemas.microsoft.com/office/drawing/2014/main" id="{E7D42356-6376-4AB2-9AA7-6DD6F1EF7C9E}"/>
+              </a:ext>
+            </a:extLst>
+          </p:cNvPr>
+          <p:cNvSpPr>
+            <a:spLocks xmlns:a="http://schemas.openxmlformats.org/drawingml/2006/main" noGrp="1"/>
+          </p:cNvSpPr>
+          <p:nvPr/>
+        </p:nvSpPr>
+        <p:spPr>
+          <a:xfrm xmlns:a="http://schemas.openxmlformats.org/drawingml/2006/main">
+            <a:off x="5429250" y="1914525"/>
+            <a:ext cx="190500" cy="613410"/>
           </a:xfrm>
           <a:prstGeom xmlns:a="http://schemas.openxmlformats.org/drawingml/2006/main" prst="rect">
             <a:avLst/>
           </a:prstGeom>
           <a:solidFill xmlns:a="http://schemas.openxmlformats.org/drawingml/2006/main">
-            <a:srgbClr val="15375F"/>
-          </a:solidFill>
-          <a:ln xmlns:a="http://schemas.openxmlformats.org/drawingml/2006/main" w="9525">
-            <a:solidFill>
-              <a:srgbClr val="FFFFFF"/>
-            </a:solidFill>
+            <a:srgbClr val="1F66AD"/>
+          </a:solidFill>
+          <a:ln xmlns:a="http://schemas.openxmlformats.org/drawingml/2006/main" w="0">
+            <a:noFill/>
+            <a:prstDash val="solid"/>
+          </a:ln>
+        </p:spPr>
+      </p:sp>
+      <p:sp>
+        <p:nvSpPr>
+          <p:cNvPr id="30" name="node-label-hired">
+            <a:extLst xmlns:a="http://schemas.openxmlformats.org/drawingml/2006/main">
+              <a:ext uri="{FF2B5EF4-FFF2-40B4-BE49-F238E27FC236}">
+                <a16:creationId xmlns:a16="http://schemas.microsoft.com/office/drawing/2014/main" id="{F805C75E-2E9D-4CF1-B791-E211D5F7A9B5}"/>
+              </a:ext>
+            </a:extLst>
+          </p:cNvPr>
+          <p:cNvSpPr>
+            <a:spLocks xmlns:a="http://schemas.openxmlformats.org/drawingml/2006/main" noGrp="1"/>
+          </p:cNvSpPr>
+          <p:nvPr/>
+        </p:nvSpPr>
+        <p:spPr>
+          <a:xfrm xmlns:a="http://schemas.openxmlformats.org/drawingml/2006/main">
+            <a:off x="5715000" y="2011680"/>
+            <a:ext cx="1028700" cy="247650"/>
+          </a:xfrm>
+          <a:prstGeom xmlns:a="http://schemas.openxmlformats.org/drawingml/2006/main" prst="rect">
+            <a:avLst/>
+          </a:prstGeom>
+          <a:noFill xmlns:a="http://schemas.openxmlformats.org/drawingml/2006/main"/>
+          <a:ln xmlns:a="http://schemas.openxmlformats.org/drawingml/2006/main" w="0">
+            <a:noFill/>
             <a:prstDash val="solid"/>
           </a:ln>
         </p:spPr>
         <p:txBody>
-          <a:bodyPr xmlns:a="http://schemas.openxmlformats.org/drawingml/2006/main" anchor="ctr"/>
+          <a:bodyPr xmlns:a="http://schemas.openxmlformats.org/drawingml/2006/main" wrap="square" lIns="38100" tIns="19050" rIns="38100" bIns="19050" anchor="ctr">
+            <a:noAutofit/>
+          </a:bodyPr>
           <a:lstStyle xmlns:a="http://schemas.openxmlformats.org/drawingml/2006/main"/>
           <a:p xmlns:a="http://schemas.openxmlformats.org/drawingml/2006/main">
-            <a:pPr algn="ctr">
-              <a:defRPr sz="1600" b="1">
-                <a:solidFill>
-                  <a:srgbClr val="FFFFFF"/>
+            <a:pPr algn="l">
+              <a:defRPr sz="1200" b="1">
+                <a:solidFill>
+                  <a:srgbClr val="172033"/>
                 </a:solidFill>
               </a:defRPr>
             </a:pPr>
             <a:r>
-              <a:rPr sz="1600" b="1">
-                <a:solidFill>
-                  <a:srgbClr val="FFFFFF"/>
+              <a:rPr sz="1200" b="1">
+                <a:solidFill>
+                  <a:srgbClr val="172033"/>
                 </a:solidFill>
               </a:rPr>
               <a:t>完成入职</a:t>
             </a:r>
           </a:p>
+        </p:txBody>
+      </p:sp>
+      <p:sp>
+        <p:nvSpPr>
+          <p:cNvPr id="31" name="node-value-hired">
+            <a:extLst xmlns:a="http://schemas.openxmlformats.org/drawingml/2006/main">
+              <a:ext uri="{FF2B5EF4-FFF2-40B4-BE49-F238E27FC236}">
+                <a16:creationId xmlns:a16="http://schemas.microsoft.com/office/drawing/2014/main" id="{41657D09-6D83-433B-8B80-E57CC3B1EF40}"/>
+              </a:ext>
+            </a:extLst>
+          </p:cNvPr>
+          <p:cNvSpPr>
+            <a:spLocks xmlns:a="http://schemas.openxmlformats.org/drawingml/2006/main" noGrp="1"/>
+          </p:cNvSpPr>
+          <p:nvPr/>
+        </p:nvSpPr>
+        <p:spPr>
+          <a:xfrm xmlns:a="http://schemas.openxmlformats.org/drawingml/2006/main">
+            <a:off x="5715000" y="2268855"/>
+            <a:ext cx="1028700" cy="171450"/>
+          </a:xfrm>
+          <a:prstGeom xmlns:a="http://schemas.openxmlformats.org/drawingml/2006/main" prst="rect">
+            <a:avLst/>
+          </a:prstGeom>
+          <a:noFill xmlns:a="http://schemas.openxmlformats.org/drawingml/2006/main"/>
+          <a:ln xmlns:a="http://schemas.openxmlformats.org/drawingml/2006/main" w="0">
+            <a:noFill/>
+            <a:prstDash val="solid"/>
+          </a:ln>
+        </p:spPr>
+        <p:txBody>
+          <a:bodyPr xmlns:a="http://schemas.openxmlformats.org/drawingml/2006/main" wrap="none" lIns="38100" tIns="19050" rIns="38100" bIns="19050" anchor="ctr">
+            <a:noAutofit/>
+          </a:bodyPr>
+          <a:lstStyle xmlns:a="http://schemas.openxmlformats.org/drawingml/2006/main"/>
           <a:p xmlns:a="http://schemas.openxmlformats.org/drawingml/2006/main">
-            <a:pPr algn="ctr">
-              <a:defRPr sz="1600" b="1">
-                <a:solidFill>
-                  <a:srgbClr val="FFFFFF"/>
+            <a:pPr algn="l">
+              <a:defRPr sz="1200" b="0">
+                <a:solidFill>
+                  <a:srgbClr val="697386"/>
                 </a:solidFill>
               </a:defRPr>
             </a:pPr>
             <a:r>
-              <a:rPr sz="1600" b="1">
-                <a:solidFill>
-                  <a:srgbClr val="FFFFFF"/>
+              <a:rPr sz="1200" b="0">
+                <a:solidFill>
+                  <a:srgbClr val="697386"/>
                 </a:solidFill>
               </a:rPr>
               <a:t>240</a:t>
@@ -1594,68 +2663,132 @@
       </p:sp>
       <p:sp>
         <p:nvSpPr>
-          <p:cNvPr id="10" name="node-preloss">
-            <a:extLst xmlns:a="http://schemas.openxmlformats.org/drawingml/2006/main">
-              <a:ext uri="{FF2B5EF4-FFF2-40B4-BE49-F238E27FC236}">
-                <a16:creationId xmlns:a16="http://schemas.microsoft.com/office/drawing/2014/main" id="{215F9C87-5A46-4BB1-A472-F71A121F72B6}"/>
-              </a:ext>
-            </a:extLst>
-          </p:cNvPr>
-          <p:cNvSpPr>
-            <a:spLocks xmlns:a="http://schemas.openxmlformats.org/drawingml/2006/main" noGrp="1"/>
-          </p:cNvSpPr>
-          <p:nvPr/>
-        </p:nvSpPr>
-        <p:spPr>
-          <a:xfrm xmlns:a="http://schemas.openxmlformats.org/drawingml/2006/main">
-            <a:off x="5105400" y="2522220"/>
-            <a:ext cx="1047750" cy="1395730"/>
+          <p:cNvPr id="32" name="node-preloss">
+            <a:extLst xmlns:a="http://schemas.openxmlformats.org/drawingml/2006/main">
+              <a:ext uri="{FF2B5EF4-FFF2-40B4-BE49-F238E27FC236}">
+                <a16:creationId xmlns:a16="http://schemas.microsoft.com/office/drawing/2014/main" id="{8299A300-270D-4F60-B41B-65A5A717C93B}"/>
+              </a:ext>
+            </a:extLst>
+          </p:cNvPr>
+          <p:cNvSpPr>
+            <a:spLocks xmlns:a="http://schemas.openxmlformats.org/drawingml/2006/main" noGrp="1"/>
+          </p:cNvSpPr>
+          <p:nvPr/>
+        </p:nvSpPr>
+        <p:spPr>
+          <a:xfrm xmlns:a="http://schemas.openxmlformats.org/drawingml/2006/main">
+            <a:off x="5429250" y="2661285"/>
+            <a:ext cx="190500" cy="1431290"/>
           </a:xfrm>
           <a:prstGeom xmlns:a="http://schemas.openxmlformats.org/drawingml/2006/main" prst="rect">
             <a:avLst/>
           </a:prstGeom>
           <a:solidFill xmlns:a="http://schemas.openxmlformats.org/drawingml/2006/main">
-            <a:srgbClr val="15375F"/>
-          </a:solidFill>
-          <a:ln xmlns:a="http://schemas.openxmlformats.org/drawingml/2006/main" w="9525">
-            <a:solidFill>
-              <a:srgbClr val="FFFFFF"/>
-            </a:solidFill>
+            <a:srgbClr val="D96F16"/>
+          </a:solidFill>
+          <a:ln xmlns:a="http://schemas.openxmlformats.org/drawingml/2006/main" w="0">
+            <a:noFill/>
+            <a:prstDash val="solid"/>
+          </a:ln>
+        </p:spPr>
+      </p:sp>
+      <p:sp>
+        <p:nvSpPr>
+          <p:cNvPr id="33" name="node-label-preloss">
+            <a:extLst xmlns:a="http://schemas.openxmlformats.org/drawingml/2006/main">
+              <a:ext uri="{FF2B5EF4-FFF2-40B4-BE49-F238E27FC236}">
+                <a16:creationId xmlns:a16="http://schemas.microsoft.com/office/drawing/2014/main" id="{D58EA2DD-9927-4877-AF3B-241BF02F0A6A}"/>
+              </a:ext>
+            </a:extLst>
+          </p:cNvPr>
+          <p:cNvSpPr>
+            <a:spLocks xmlns:a="http://schemas.openxmlformats.org/drawingml/2006/main" noGrp="1"/>
+          </p:cNvSpPr>
+          <p:nvPr/>
+        </p:nvSpPr>
+        <p:spPr>
+          <a:xfrm xmlns:a="http://schemas.openxmlformats.org/drawingml/2006/main">
+            <a:off x="5715000" y="3167380"/>
+            <a:ext cx="1028700" cy="247650"/>
+          </a:xfrm>
+          <a:prstGeom xmlns:a="http://schemas.openxmlformats.org/drawingml/2006/main" prst="rect">
+            <a:avLst/>
+          </a:prstGeom>
+          <a:noFill xmlns:a="http://schemas.openxmlformats.org/drawingml/2006/main"/>
+          <a:ln xmlns:a="http://schemas.openxmlformats.org/drawingml/2006/main" w="0">
+            <a:noFill/>
             <a:prstDash val="solid"/>
           </a:ln>
         </p:spPr>
         <p:txBody>
-          <a:bodyPr xmlns:a="http://schemas.openxmlformats.org/drawingml/2006/main" anchor="ctr"/>
+          <a:bodyPr xmlns:a="http://schemas.openxmlformats.org/drawingml/2006/main" wrap="square" lIns="38100" tIns="19050" rIns="38100" bIns="19050" anchor="ctr">
+            <a:noAutofit/>
+          </a:bodyPr>
           <a:lstStyle xmlns:a="http://schemas.openxmlformats.org/drawingml/2006/main"/>
           <a:p xmlns:a="http://schemas.openxmlformats.org/drawingml/2006/main">
-            <a:pPr algn="ctr">
-              <a:defRPr sz="1600" b="1">
-                <a:solidFill>
-                  <a:srgbClr val="FFFFFF"/>
+            <a:pPr algn="l">
+              <a:defRPr sz="1200" b="1">
+                <a:solidFill>
+                  <a:srgbClr val="172033"/>
                 </a:solidFill>
               </a:defRPr>
             </a:pPr>
             <a:r>
-              <a:rPr sz="1600" b="1">
-                <a:solidFill>
-                  <a:srgbClr val="FFFFFF"/>
+              <a:rPr sz="1200" b="1">
+                <a:solidFill>
+                  <a:srgbClr val="172033"/>
                 </a:solidFill>
               </a:rPr>
               <a:t>入职前损耗</a:t>
             </a:r>
           </a:p>
+        </p:txBody>
+      </p:sp>
+      <p:sp>
+        <p:nvSpPr>
+          <p:cNvPr id="34" name="node-value-preloss">
+            <a:extLst xmlns:a="http://schemas.openxmlformats.org/drawingml/2006/main">
+              <a:ext uri="{FF2B5EF4-FFF2-40B4-BE49-F238E27FC236}">
+                <a16:creationId xmlns:a16="http://schemas.microsoft.com/office/drawing/2014/main" id="{1931C371-B10E-4860-92DB-9A1357C29B39}"/>
+              </a:ext>
+            </a:extLst>
+          </p:cNvPr>
+          <p:cNvSpPr>
+            <a:spLocks xmlns:a="http://schemas.openxmlformats.org/drawingml/2006/main" noGrp="1"/>
+          </p:cNvSpPr>
+          <p:nvPr/>
+        </p:nvSpPr>
+        <p:spPr>
+          <a:xfrm xmlns:a="http://schemas.openxmlformats.org/drawingml/2006/main">
+            <a:off x="5715000" y="3424555"/>
+            <a:ext cx="1028700" cy="171450"/>
+          </a:xfrm>
+          <a:prstGeom xmlns:a="http://schemas.openxmlformats.org/drawingml/2006/main" prst="rect">
+            <a:avLst/>
+          </a:prstGeom>
+          <a:noFill xmlns:a="http://schemas.openxmlformats.org/drawingml/2006/main"/>
+          <a:ln xmlns:a="http://schemas.openxmlformats.org/drawingml/2006/main" w="0">
+            <a:noFill/>
+            <a:prstDash val="solid"/>
+          </a:ln>
+        </p:spPr>
+        <p:txBody>
+          <a:bodyPr xmlns:a="http://schemas.openxmlformats.org/drawingml/2006/main" wrap="none" lIns="38100" tIns="19050" rIns="38100" bIns="19050" anchor="ctr">
+            <a:noAutofit/>
+          </a:bodyPr>
+          <a:lstStyle xmlns:a="http://schemas.openxmlformats.org/drawingml/2006/main"/>
           <a:p xmlns:a="http://schemas.openxmlformats.org/drawingml/2006/main">
-            <a:pPr algn="ctr">
-              <a:defRPr sz="1600" b="1">
-                <a:solidFill>
-                  <a:srgbClr val="FFFFFF"/>
+            <a:pPr algn="l">
+              <a:defRPr sz="1200" b="0">
+                <a:solidFill>
+                  <a:srgbClr val="697386"/>
                 </a:solidFill>
               </a:defRPr>
             </a:pPr>
             <a:r>
-              <a:rPr sz="1600" b="1">
-                <a:solidFill>
-                  <a:srgbClr val="FFFFFF"/>
+              <a:rPr sz="1200" b="0">
+                <a:solidFill>
+                  <a:srgbClr val="697386"/>
                 </a:solidFill>
               </a:rPr>
               <a:t>560</a:t>
@@ -1665,68 +2798,132 @@
       </p:sp>
       <p:sp>
         <p:nvSpPr>
-          <p:cNvPr id="11" name="node-closed">
-            <a:extLst xmlns:a="http://schemas.openxmlformats.org/drawingml/2006/main">
-              <a:ext uri="{FF2B5EF4-FFF2-40B4-BE49-F238E27FC236}">
-                <a16:creationId xmlns:a16="http://schemas.microsoft.com/office/drawing/2014/main" id="{93CD0D3D-64D6-4FDE-AAA6-8DDE6FF27611}"/>
-              </a:ext>
-            </a:extLst>
-          </p:cNvPr>
-          <p:cNvSpPr>
-            <a:spLocks xmlns:a="http://schemas.openxmlformats.org/drawingml/2006/main" noGrp="1"/>
-          </p:cNvSpPr>
-          <p:nvPr/>
-        </p:nvSpPr>
-        <p:spPr>
-          <a:xfrm xmlns:a="http://schemas.openxmlformats.org/drawingml/2006/main">
-            <a:off x="5105400" y="4127500"/>
-            <a:ext cx="1047750" cy="996950"/>
+          <p:cNvPr id="35" name="node-closed">
+            <a:extLst xmlns:a="http://schemas.openxmlformats.org/drawingml/2006/main">
+              <a:ext uri="{FF2B5EF4-FFF2-40B4-BE49-F238E27FC236}">
+                <a16:creationId xmlns:a16="http://schemas.microsoft.com/office/drawing/2014/main" id="{BF0F2434-FA23-4357-861B-C71DED764529}"/>
+              </a:ext>
+            </a:extLst>
+          </p:cNvPr>
+          <p:cNvSpPr>
+            <a:spLocks xmlns:a="http://schemas.openxmlformats.org/drawingml/2006/main" noGrp="1"/>
+          </p:cNvSpPr>
+          <p:nvPr/>
+        </p:nvSpPr>
+        <p:spPr>
+          <a:xfrm xmlns:a="http://schemas.openxmlformats.org/drawingml/2006/main">
+            <a:off x="5429250" y="4225925"/>
+            <a:ext cx="190500" cy="1022350"/>
           </a:xfrm>
           <a:prstGeom xmlns:a="http://schemas.openxmlformats.org/drawingml/2006/main" prst="rect">
             <a:avLst/>
           </a:prstGeom>
           <a:solidFill xmlns:a="http://schemas.openxmlformats.org/drawingml/2006/main">
-            <a:srgbClr val="15375F"/>
-          </a:solidFill>
-          <a:ln xmlns:a="http://schemas.openxmlformats.org/drawingml/2006/main" w="9525">
-            <a:solidFill>
-              <a:srgbClr val="FFFFFF"/>
-            </a:solidFill>
+            <a:srgbClr val="D96F16"/>
+          </a:solidFill>
+          <a:ln xmlns:a="http://schemas.openxmlformats.org/drawingml/2006/main" w="0">
+            <a:noFill/>
+            <a:prstDash val="solid"/>
+          </a:ln>
+        </p:spPr>
+      </p:sp>
+      <p:sp>
+        <p:nvSpPr>
+          <p:cNvPr id="36" name="node-label-closed">
+            <a:extLst xmlns:a="http://schemas.openxmlformats.org/drawingml/2006/main">
+              <a:ext uri="{FF2B5EF4-FFF2-40B4-BE49-F238E27FC236}">
+                <a16:creationId xmlns:a16="http://schemas.microsoft.com/office/drawing/2014/main" id="{55FB9FBF-768C-4D89-A86F-55D5195AEF01}"/>
+              </a:ext>
+            </a:extLst>
+          </p:cNvPr>
+          <p:cNvSpPr>
+            <a:spLocks xmlns:a="http://schemas.openxmlformats.org/drawingml/2006/main" noGrp="1"/>
+          </p:cNvSpPr>
+          <p:nvPr/>
+        </p:nvSpPr>
+        <p:spPr>
+          <a:xfrm xmlns:a="http://schemas.openxmlformats.org/drawingml/2006/main">
+            <a:off x="5715000" y="4527550"/>
+            <a:ext cx="1028700" cy="247650"/>
+          </a:xfrm>
+          <a:prstGeom xmlns:a="http://schemas.openxmlformats.org/drawingml/2006/main" prst="rect">
+            <a:avLst/>
+          </a:prstGeom>
+          <a:noFill xmlns:a="http://schemas.openxmlformats.org/drawingml/2006/main"/>
+          <a:ln xmlns:a="http://schemas.openxmlformats.org/drawingml/2006/main" w="0">
+            <a:noFill/>
             <a:prstDash val="solid"/>
           </a:ln>
         </p:spPr>
         <p:txBody>
-          <a:bodyPr xmlns:a="http://schemas.openxmlformats.org/drawingml/2006/main" anchor="ctr"/>
+          <a:bodyPr xmlns:a="http://schemas.openxmlformats.org/drawingml/2006/main" wrap="square" lIns="38100" tIns="19050" rIns="38100" bIns="19050" anchor="ctr">
+            <a:noAutofit/>
+          </a:bodyPr>
           <a:lstStyle xmlns:a="http://schemas.openxmlformats.org/drawingml/2006/main"/>
           <a:p xmlns:a="http://schemas.openxmlformats.org/drawingml/2006/main">
-            <a:pPr algn="ctr">
-              <a:defRPr sz="1600" b="1">
-                <a:solidFill>
-                  <a:srgbClr val="FFFFFF"/>
+            <a:pPr algn="l">
+              <a:defRPr sz="1200" b="1">
+                <a:solidFill>
+                  <a:srgbClr val="172033"/>
                 </a:solidFill>
               </a:defRPr>
             </a:pPr>
             <a:r>
-              <a:rPr sz="1600" b="1">
-                <a:solidFill>
-                  <a:srgbClr val="FFFFFF"/>
+              <a:rPr sz="1200" b="1">
+                <a:solidFill>
+                  <a:srgbClr val="172033"/>
                 </a:solidFill>
               </a:rPr>
               <a:t>筛选关闭</a:t>
             </a:r>
           </a:p>
+        </p:txBody>
+      </p:sp>
+      <p:sp>
+        <p:nvSpPr>
+          <p:cNvPr id="37" name="node-value-closed">
+            <a:extLst xmlns:a="http://schemas.openxmlformats.org/drawingml/2006/main">
+              <a:ext uri="{FF2B5EF4-FFF2-40B4-BE49-F238E27FC236}">
+                <a16:creationId xmlns:a16="http://schemas.microsoft.com/office/drawing/2014/main" id="{AAC1BE0E-217A-4FB2-8981-8242E262ADA4}"/>
+              </a:ext>
+            </a:extLst>
+          </p:cNvPr>
+          <p:cNvSpPr>
+            <a:spLocks xmlns:a="http://schemas.openxmlformats.org/drawingml/2006/main" noGrp="1"/>
+          </p:cNvSpPr>
+          <p:nvPr/>
+        </p:nvSpPr>
+        <p:spPr>
+          <a:xfrm xmlns:a="http://schemas.openxmlformats.org/drawingml/2006/main">
+            <a:off x="5715000" y="4784725"/>
+            <a:ext cx="1028700" cy="171450"/>
+          </a:xfrm>
+          <a:prstGeom xmlns:a="http://schemas.openxmlformats.org/drawingml/2006/main" prst="rect">
+            <a:avLst/>
+          </a:prstGeom>
+          <a:noFill xmlns:a="http://schemas.openxmlformats.org/drawingml/2006/main"/>
+          <a:ln xmlns:a="http://schemas.openxmlformats.org/drawingml/2006/main" w="0">
+            <a:noFill/>
+            <a:prstDash val="solid"/>
+          </a:ln>
+        </p:spPr>
+        <p:txBody>
+          <a:bodyPr xmlns:a="http://schemas.openxmlformats.org/drawingml/2006/main" wrap="none" lIns="38100" tIns="19050" rIns="38100" bIns="19050" anchor="ctr">
+            <a:noAutofit/>
+          </a:bodyPr>
+          <a:lstStyle xmlns:a="http://schemas.openxmlformats.org/drawingml/2006/main"/>
           <a:p xmlns:a="http://schemas.openxmlformats.org/drawingml/2006/main">
-            <a:pPr algn="ctr">
-              <a:defRPr sz="1600" b="1">
-                <a:solidFill>
-                  <a:srgbClr val="FFFFFF"/>
+            <a:pPr algn="l">
+              <a:defRPr sz="1200" b="0">
+                <a:solidFill>
+                  <a:srgbClr val="697386"/>
                 </a:solidFill>
               </a:defRPr>
             </a:pPr>
             <a:r>
-              <a:rPr sz="1600" b="1">
-                <a:solidFill>
-                  <a:srgbClr val="FFFFFF"/>
+              <a:rPr sz="1200" b="0">
+                <a:solidFill>
+                  <a:srgbClr val="697386"/>
                 </a:solidFill>
               </a:rPr>
               <a:t>400</a:t>
@@ -1736,22 +2933,22 @@
       </p:sp>
       <p:sp>
         <p:nvSpPr>
-          <p:cNvPr id="12" name="layer-3">
-            <a:extLst xmlns:a="http://schemas.openxmlformats.org/drawingml/2006/main">
-              <a:ext uri="{FF2B5EF4-FFF2-40B4-BE49-F238E27FC236}">
-                <a16:creationId xmlns:a16="http://schemas.microsoft.com/office/drawing/2014/main" id="{5BFCDE5F-A42B-496A-AD94-8B2AEC23AEAF}"/>
-              </a:ext>
-            </a:extLst>
-          </p:cNvPr>
-          <p:cNvSpPr>
-            <a:spLocks xmlns:a="http://schemas.openxmlformats.org/drawingml/2006/main" noGrp="1"/>
-          </p:cNvSpPr>
-          <p:nvPr/>
-        </p:nvSpPr>
-        <p:spPr>
-          <a:xfrm xmlns:a="http://schemas.openxmlformats.org/drawingml/2006/main">
-            <a:off x="5105400" y="1352550"/>
-            <a:ext cx="1047750" cy="266700"/>
+          <p:cNvPr id="38" name="layer-4">
+            <a:extLst xmlns:a="http://schemas.openxmlformats.org/drawingml/2006/main">
+              <a:ext uri="{FF2B5EF4-FFF2-40B4-BE49-F238E27FC236}">
+                <a16:creationId xmlns:a16="http://schemas.microsoft.com/office/drawing/2014/main" id="{98DF1724-9052-448F-B1AF-54C066F5E370}"/>
+              </a:ext>
+            </a:extLst>
+          </p:cNvPr>
+          <p:cNvSpPr>
+            <a:spLocks xmlns:a="http://schemas.openxmlformats.org/drawingml/2006/main" noGrp="1"/>
+          </p:cNvSpPr>
+          <p:nvPr/>
+        </p:nvSpPr>
+        <p:spPr>
+          <a:xfrm xmlns:a="http://schemas.openxmlformats.org/drawingml/2006/main">
+            <a:off x="6486525" y="1333500"/>
+            <a:ext cx="1838325" cy="438150"/>
           </a:xfrm>
           <a:prstGeom xmlns:a="http://schemas.openxmlformats.org/drawingml/2006/main" prst="rect">
             <a:avLst/>
@@ -1763,91 +2960,157 @@
           </a:ln>
         </p:spPr>
         <p:txBody>
-          <a:bodyPr xmlns:a="http://schemas.openxmlformats.org/drawingml/2006/main" anchor="ctr"/>
+          <a:bodyPr xmlns:a="http://schemas.openxmlformats.org/drawingml/2006/main" wrap="square" lIns="38100" tIns="19050" rIns="38100" bIns="19050" anchor="ctr">
+            <a:noAutofit/>
+          </a:bodyPr>
           <a:lstStyle xmlns:a="http://schemas.openxmlformats.org/drawingml/2006/main"/>
           <a:p xmlns:a="http://schemas.openxmlformats.org/drawingml/2006/main">
             <a:pPr algn="ctr">
-              <a:defRPr sz="1600" b="1">
+              <a:defRPr sz="1200" b="1">
                 <a:solidFill>
                   <a:srgbClr val="15375F"/>
                 </a:solidFill>
               </a:defRPr>
             </a:pPr>
             <a:r>
-              <a:rPr sz="1600" b="1">
+              <a:rPr sz="1200" b="1">
                 <a:solidFill>
                   <a:srgbClr val="15375F"/>
                 </a:solidFill>
               </a:rPr>
-              <a:t>入职去向｜入职率 20%</a:t>
+              <a:t>12 个月状态；留任率 25%</a:t>
             </a:r>
           </a:p>
         </p:txBody>
       </p:sp>
       <p:sp>
         <p:nvSpPr>
-          <p:cNvPr id="13" name="node-retained">
-            <a:extLst xmlns:a="http://schemas.openxmlformats.org/drawingml/2006/main">
-              <a:ext uri="{FF2B5EF4-FFF2-40B4-BE49-F238E27FC236}">
-                <a16:creationId xmlns:a16="http://schemas.microsoft.com/office/drawing/2014/main" id="{3C72C80E-7B1D-4B4C-BC95-8F79A39A9377}"/>
-              </a:ext>
-            </a:extLst>
-          </p:cNvPr>
-          <p:cNvSpPr>
-            <a:spLocks xmlns:a="http://schemas.openxmlformats.org/drawingml/2006/main" noGrp="1"/>
-          </p:cNvSpPr>
-          <p:nvPr/>
-        </p:nvSpPr>
-        <p:spPr>
-          <a:xfrm xmlns:a="http://schemas.openxmlformats.org/drawingml/2006/main">
-            <a:off x="7239000" y="1714500"/>
-            <a:ext cx="1047750" cy="323850"/>
+          <p:cNvPr id="39" name="node-retained">
+            <a:extLst xmlns:a="http://schemas.openxmlformats.org/drawingml/2006/main">
+              <a:ext uri="{FF2B5EF4-FFF2-40B4-BE49-F238E27FC236}">
+                <a16:creationId xmlns:a16="http://schemas.microsoft.com/office/drawing/2014/main" id="{68FFF944-CA9E-417E-9F4C-A7B215690668}"/>
+              </a:ext>
+            </a:extLst>
+          </p:cNvPr>
+          <p:cNvSpPr>
+            <a:spLocks xmlns:a="http://schemas.openxmlformats.org/drawingml/2006/main" noGrp="1"/>
+          </p:cNvSpPr>
+          <p:nvPr/>
+        </p:nvSpPr>
+        <p:spPr>
+          <a:xfrm xmlns:a="http://schemas.openxmlformats.org/drawingml/2006/main">
+            <a:off x="7353300" y="1847850"/>
+            <a:ext cx="190500" cy="153352"/>
           </a:xfrm>
           <a:prstGeom xmlns:a="http://schemas.openxmlformats.org/drawingml/2006/main" prst="rect">
             <a:avLst/>
           </a:prstGeom>
           <a:solidFill xmlns:a="http://schemas.openxmlformats.org/drawingml/2006/main">
-            <a:srgbClr val="15375F"/>
-          </a:solidFill>
-          <a:ln xmlns:a="http://schemas.openxmlformats.org/drawingml/2006/main" w="9525">
-            <a:solidFill>
-              <a:srgbClr val="FFFFFF"/>
-            </a:solidFill>
+            <a:srgbClr val="1F66AD"/>
+          </a:solidFill>
+          <a:ln xmlns:a="http://schemas.openxmlformats.org/drawingml/2006/main" w="0">
+            <a:noFill/>
+            <a:prstDash val="solid"/>
+          </a:ln>
+        </p:spPr>
+      </p:sp>
+      <p:sp>
+        <p:nvSpPr>
+          <p:cNvPr id="40" name="node-label-retained">
+            <a:extLst xmlns:a="http://schemas.openxmlformats.org/drawingml/2006/main">
+              <a:ext uri="{FF2B5EF4-FFF2-40B4-BE49-F238E27FC236}">
+                <a16:creationId xmlns:a16="http://schemas.microsoft.com/office/drawing/2014/main" id="{384D644C-2B72-42F1-B826-0589DEB2C8B5}"/>
+              </a:ext>
+            </a:extLst>
+          </p:cNvPr>
+          <p:cNvSpPr>
+            <a:spLocks xmlns:a="http://schemas.openxmlformats.org/drawingml/2006/main" noGrp="1"/>
+          </p:cNvSpPr>
+          <p:nvPr/>
+        </p:nvSpPr>
+        <p:spPr>
+          <a:xfrm xmlns:a="http://schemas.openxmlformats.org/drawingml/2006/main">
+            <a:off x="7639050" y="1714976"/>
+            <a:ext cx="1028700" cy="247650"/>
+          </a:xfrm>
+          <a:prstGeom xmlns:a="http://schemas.openxmlformats.org/drawingml/2006/main" prst="rect">
+            <a:avLst/>
+          </a:prstGeom>
+          <a:noFill xmlns:a="http://schemas.openxmlformats.org/drawingml/2006/main"/>
+          <a:ln xmlns:a="http://schemas.openxmlformats.org/drawingml/2006/main" w="0">
+            <a:noFill/>
             <a:prstDash val="solid"/>
           </a:ln>
         </p:spPr>
         <p:txBody>
-          <a:bodyPr xmlns:a="http://schemas.openxmlformats.org/drawingml/2006/main" anchor="ctr"/>
+          <a:bodyPr xmlns:a="http://schemas.openxmlformats.org/drawingml/2006/main" wrap="square" lIns="38100" tIns="19050" rIns="38100" bIns="19050" anchor="ctr">
+            <a:noAutofit/>
+          </a:bodyPr>
           <a:lstStyle xmlns:a="http://schemas.openxmlformats.org/drawingml/2006/main"/>
           <a:p xmlns:a="http://schemas.openxmlformats.org/drawingml/2006/main">
-            <a:pPr algn="ctr">
-              <a:defRPr sz="1600" b="1">
-                <a:solidFill>
-                  <a:srgbClr val="FFFFFF"/>
+            <a:pPr algn="l">
+              <a:defRPr sz="1200" b="1">
+                <a:solidFill>
+                  <a:srgbClr val="172033"/>
                 </a:solidFill>
               </a:defRPr>
             </a:pPr>
             <a:r>
-              <a:rPr sz="1600" b="1">
-                <a:solidFill>
-                  <a:srgbClr val="FFFFFF"/>
+              <a:rPr sz="1200" b="1">
+                <a:solidFill>
+                  <a:srgbClr val="172033"/>
                 </a:solidFill>
               </a:rPr>
               <a:t>留任</a:t>
             </a:r>
           </a:p>
+        </p:txBody>
+      </p:sp>
+      <p:sp>
+        <p:nvSpPr>
+          <p:cNvPr id="41" name="node-value-retained">
+            <a:extLst xmlns:a="http://schemas.openxmlformats.org/drawingml/2006/main">
+              <a:ext uri="{FF2B5EF4-FFF2-40B4-BE49-F238E27FC236}">
+                <a16:creationId xmlns:a16="http://schemas.microsoft.com/office/drawing/2014/main" id="{9BCF6BAF-D754-4C80-8FAF-E450B13B870B}"/>
+              </a:ext>
+            </a:extLst>
+          </p:cNvPr>
+          <p:cNvSpPr>
+            <a:spLocks xmlns:a="http://schemas.openxmlformats.org/drawingml/2006/main" noGrp="1"/>
+          </p:cNvSpPr>
+          <p:nvPr/>
+        </p:nvSpPr>
+        <p:spPr>
+          <a:xfrm xmlns:a="http://schemas.openxmlformats.org/drawingml/2006/main">
+            <a:off x="7639050" y="1972151"/>
+            <a:ext cx="1028700" cy="171450"/>
+          </a:xfrm>
+          <a:prstGeom xmlns:a="http://schemas.openxmlformats.org/drawingml/2006/main" prst="rect">
+            <a:avLst/>
+          </a:prstGeom>
+          <a:noFill xmlns:a="http://schemas.openxmlformats.org/drawingml/2006/main"/>
+          <a:ln xmlns:a="http://schemas.openxmlformats.org/drawingml/2006/main" w="0">
+            <a:noFill/>
+            <a:prstDash val="solid"/>
+          </a:ln>
+        </p:spPr>
+        <p:txBody>
+          <a:bodyPr xmlns:a="http://schemas.openxmlformats.org/drawingml/2006/main" wrap="none" lIns="38100" tIns="19050" rIns="38100" bIns="19050" anchor="ctr">
+            <a:noAutofit/>
+          </a:bodyPr>
+          <a:lstStyle xmlns:a="http://schemas.openxmlformats.org/drawingml/2006/main"/>
           <a:p xmlns:a="http://schemas.openxmlformats.org/drawingml/2006/main">
-            <a:pPr algn="ctr">
-              <a:defRPr sz="1600" b="1">
-                <a:solidFill>
-                  <a:srgbClr val="FFFFFF"/>
+            <a:pPr algn="l">
+              <a:defRPr sz="1200" b="0">
+                <a:solidFill>
+                  <a:srgbClr val="697386"/>
                 </a:solidFill>
               </a:defRPr>
             </a:pPr>
             <a:r>
-              <a:rPr sz="1600" b="1">
-                <a:solidFill>
-                  <a:srgbClr val="FFFFFF"/>
+              <a:rPr sz="1200" b="0">
+                <a:solidFill>
+                  <a:srgbClr val="697386"/>
                 </a:solidFill>
               </a:rPr>
               <a:t>60</a:t>
@@ -1857,68 +3120,132 @@
       </p:sp>
       <p:sp>
         <p:nvSpPr>
-          <p:cNvPr id="14" name="node-turnover">
-            <a:extLst xmlns:a="http://schemas.openxmlformats.org/drawingml/2006/main">
-              <a:ext uri="{FF2B5EF4-FFF2-40B4-BE49-F238E27FC236}">
-                <a16:creationId xmlns:a16="http://schemas.microsoft.com/office/drawing/2014/main" id="{B269CF1C-595C-40A5-B8A5-81ADBF7A061E}"/>
-              </a:ext>
-            </a:extLst>
-          </p:cNvPr>
-          <p:cNvSpPr>
-            <a:spLocks xmlns:a="http://schemas.openxmlformats.org/drawingml/2006/main" noGrp="1"/>
-          </p:cNvSpPr>
-          <p:nvPr/>
-        </p:nvSpPr>
-        <p:spPr>
-          <a:xfrm xmlns:a="http://schemas.openxmlformats.org/drawingml/2006/main">
-            <a:off x="7239000" y="2247900"/>
-            <a:ext cx="1047750" cy="417195"/>
+          <p:cNvPr id="42" name="node-turnover">
+            <a:extLst xmlns:a="http://schemas.openxmlformats.org/drawingml/2006/main">
+              <a:ext uri="{FF2B5EF4-FFF2-40B4-BE49-F238E27FC236}">
+                <a16:creationId xmlns:a16="http://schemas.microsoft.com/office/drawing/2014/main" id="{9A93CF2E-6825-48FC-B24A-1AA21D380A43}"/>
+              </a:ext>
+            </a:extLst>
+          </p:cNvPr>
+          <p:cNvSpPr>
+            <a:spLocks xmlns:a="http://schemas.openxmlformats.org/drawingml/2006/main" noGrp="1"/>
+          </p:cNvSpPr>
+          <p:nvPr/>
+        </p:nvSpPr>
+        <p:spPr>
+          <a:xfrm xmlns:a="http://schemas.openxmlformats.org/drawingml/2006/main">
+            <a:off x="7353300" y="2134553"/>
+            <a:ext cx="190500" cy="460058"/>
           </a:xfrm>
           <a:prstGeom xmlns:a="http://schemas.openxmlformats.org/drawingml/2006/main" prst="rect">
             <a:avLst/>
           </a:prstGeom>
           <a:solidFill xmlns:a="http://schemas.openxmlformats.org/drawingml/2006/main">
-            <a:srgbClr val="E8872D"/>
-          </a:solidFill>
-          <a:ln xmlns:a="http://schemas.openxmlformats.org/drawingml/2006/main" w="9525">
-            <a:solidFill>
-              <a:srgbClr val="FFFFFF"/>
-            </a:solidFill>
+            <a:srgbClr val="D96F16"/>
+          </a:solidFill>
+          <a:ln xmlns:a="http://schemas.openxmlformats.org/drawingml/2006/main" w="0">
+            <a:noFill/>
+            <a:prstDash val="solid"/>
+          </a:ln>
+        </p:spPr>
+      </p:sp>
+      <p:sp>
+        <p:nvSpPr>
+          <p:cNvPr id="43" name="node-label-turnover">
+            <a:extLst xmlns:a="http://schemas.openxmlformats.org/drawingml/2006/main">
+              <a:ext uri="{FF2B5EF4-FFF2-40B4-BE49-F238E27FC236}">
+                <a16:creationId xmlns:a16="http://schemas.microsoft.com/office/drawing/2014/main" id="{C503A03C-8852-49E8-B89C-6A0E1DB32373}"/>
+              </a:ext>
+            </a:extLst>
+          </p:cNvPr>
+          <p:cNvSpPr>
+            <a:spLocks xmlns:a="http://schemas.openxmlformats.org/drawingml/2006/main" noGrp="1"/>
+          </p:cNvSpPr>
+          <p:nvPr/>
+        </p:nvSpPr>
+        <p:spPr>
+          <a:xfrm xmlns:a="http://schemas.openxmlformats.org/drawingml/2006/main">
+            <a:off x="7639050" y="2155031"/>
+            <a:ext cx="1028700" cy="247650"/>
+          </a:xfrm>
+          <a:prstGeom xmlns:a="http://schemas.openxmlformats.org/drawingml/2006/main" prst="rect">
+            <a:avLst/>
+          </a:prstGeom>
+          <a:noFill xmlns:a="http://schemas.openxmlformats.org/drawingml/2006/main"/>
+          <a:ln xmlns:a="http://schemas.openxmlformats.org/drawingml/2006/main" w="0">
+            <a:noFill/>
             <a:prstDash val="solid"/>
           </a:ln>
         </p:spPr>
         <p:txBody>
-          <a:bodyPr xmlns:a="http://schemas.openxmlformats.org/drawingml/2006/main" anchor="ctr"/>
+          <a:bodyPr xmlns:a="http://schemas.openxmlformats.org/drawingml/2006/main" wrap="square" lIns="38100" tIns="19050" rIns="38100" bIns="19050" anchor="ctr">
+            <a:noAutofit/>
+          </a:bodyPr>
           <a:lstStyle xmlns:a="http://schemas.openxmlformats.org/drawingml/2006/main"/>
           <a:p xmlns:a="http://schemas.openxmlformats.org/drawingml/2006/main">
-            <a:pPr algn="ctr">
-              <a:defRPr sz="1600" b="1">
-                <a:solidFill>
-                  <a:srgbClr val="FFFFFF"/>
+            <a:pPr algn="l">
+              <a:defRPr sz="1200" b="1">
+                <a:solidFill>
+                  <a:srgbClr val="172033"/>
                 </a:solidFill>
               </a:defRPr>
             </a:pPr>
             <a:r>
-              <a:rPr sz="1600" b="1">
-                <a:solidFill>
-                  <a:srgbClr val="FFFFFF"/>
+              <a:rPr sz="1200" b="1">
+                <a:solidFill>
+                  <a:srgbClr val="172033"/>
                 </a:solidFill>
               </a:rPr>
               <a:t>入职后流失</a:t>
             </a:r>
           </a:p>
+        </p:txBody>
+      </p:sp>
+      <p:sp>
+        <p:nvSpPr>
+          <p:cNvPr id="44" name="node-value-turnover">
+            <a:extLst xmlns:a="http://schemas.openxmlformats.org/drawingml/2006/main">
+              <a:ext uri="{FF2B5EF4-FFF2-40B4-BE49-F238E27FC236}">
+                <a16:creationId xmlns:a16="http://schemas.microsoft.com/office/drawing/2014/main" id="{A96B1F72-2302-434F-91C1-A9F9499E3B7A}"/>
+              </a:ext>
+            </a:extLst>
+          </p:cNvPr>
+          <p:cNvSpPr>
+            <a:spLocks xmlns:a="http://schemas.openxmlformats.org/drawingml/2006/main" noGrp="1"/>
+          </p:cNvSpPr>
+          <p:nvPr/>
+        </p:nvSpPr>
+        <p:spPr>
+          <a:xfrm xmlns:a="http://schemas.openxmlformats.org/drawingml/2006/main">
+            <a:off x="7639050" y="2412206"/>
+            <a:ext cx="1028700" cy="171450"/>
+          </a:xfrm>
+          <a:prstGeom xmlns:a="http://schemas.openxmlformats.org/drawingml/2006/main" prst="rect">
+            <a:avLst/>
+          </a:prstGeom>
+          <a:noFill xmlns:a="http://schemas.openxmlformats.org/drawingml/2006/main"/>
+          <a:ln xmlns:a="http://schemas.openxmlformats.org/drawingml/2006/main" w="0">
+            <a:noFill/>
+            <a:prstDash val="solid"/>
+          </a:ln>
+        </p:spPr>
+        <p:txBody>
+          <a:bodyPr xmlns:a="http://schemas.openxmlformats.org/drawingml/2006/main" wrap="none" lIns="38100" tIns="19050" rIns="38100" bIns="19050" anchor="ctr">
+            <a:noAutofit/>
+          </a:bodyPr>
+          <a:lstStyle xmlns:a="http://schemas.openxmlformats.org/drawingml/2006/main"/>
           <a:p xmlns:a="http://schemas.openxmlformats.org/drawingml/2006/main">
-            <a:pPr algn="ctr">
-              <a:defRPr sz="1600" b="1">
-                <a:solidFill>
-                  <a:srgbClr val="FFFFFF"/>
+            <a:pPr algn="l">
+              <a:defRPr sz="1200" b="0">
+                <a:solidFill>
+                  <a:srgbClr val="697386"/>
                 </a:solidFill>
               </a:defRPr>
             </a:pPr>
             <a:r>
-              <a:rPr sz="1600" b="1">
-                <a:solidFill>
-                  <a:srgbClr val="FFFFFF"/>
+              <a:rPr sz="1200" b="0">
+                <a:solidFill>
+                  <a:srgbClr val="697386"/>
                 </a:solidFill>
               </a:rPr>
               <a:t>180</a:t>
@@ -1928,68 +3255,132 @@
       </p:sp>
       <p:sp>
         <p:nvSpPr>
-          <p:cNvPr id="15" name="node-not_hired">
-            <a:extLst xmlns:a="http://schemas.openxmlformats.org/drawingml/2006/main">
-              <a:ext uri="{FF2B5EF4-FFF2-40B4-BE49-F238E27FC236}">
-                <a16:creationId xmlns:a16="http://schemas.microsoft.com/office/drawing/2014/main" id="{EE9D5868-CA87-47DF-82EE-A27A0FB4259F}"/>
-              </a:ext>
-            </a:extLst>
-          </p:cNvPr>
-          <p:cNvSpPr>
-            <a:spLocks xmlns:a="http://schemas.openxmlformats.org/drawingml/2006/main" noGrp="1"/>
-          </p:cNvSpPr>
-          <p:nvPr/>
-        </p:nvSpPr>
-        <p:spPr>
-          <a:xfrm xmlns:a="http://schemas.openxmlformats.org/drawingml/2006/main">
-            <a:off x="7239000" y="2874645"/>
-            <a:ext cx="1047750" cy="1297940"/>
+          <p:cNvPr id="45" name="node-not_hired">
+            <a:extLst xmlns:a="http://schemas.openxmlformats.org/drawingml/2006/main">
+              <a:ext uri="{FF2B5EF4-FFF2-40B4-BE49-F238E27FC236}">
+                <a16:creationId xmlns:a16="http://schemas.microsoft.com/office/drawing/2014/main" id="{5730C4FB-189C-4528-A045-31FD985B1B6F}"/>
+              </a:ext>
+            </a:extLst>
+          </p:cNvPr>
+          <p:cNvSpPr>
+            <a:spLocks xmlns:a="http://schemas.openxmlformats.org/drawingml/2006/main" noGrp="1"/>
+          </p:cNvSpPr>
+          <p:nvPr/>
+        </p:nvSpPr>
+        <p:spPr>
+          <a:xfrm xmlns:a="http://schemas.openxmlformats.org/drawingml/2006/main">
+            <a:off x="7353300" y="2727960"/>
+            <a:ext cx="190500" cy="1431290"/>
           </a:xfrm>
           <a:prstGeom xmlns:a="http://schemas.openxmlformats.org/drawingml/2006/main" prst="rect">
             <a:avLst/>
           </a:prstGeom>
           <a:solidFill xmlns:a="http://schemas.openxmlformats.org/drawingml/2006/main">
-            <a:srgbClr val="E8872D"/>
-          </a:solidFill>
-          <a:ln xmlns:a="http://schemas.openxmlformats.org/drawingml/2006/main" w="9525">
-            <a:solidFill>
-              <a:srgbClr val="FFFFFF"/>
-            </a:solidFill>
+            <a:srgbClr val="D96F16"/>
+          </a:solidFill>
+          <a:ln xmlns:a="http://schemas.openxmlformats.org/drawingml/2006/main" w="0">
+            <a:noFill/>
+            <a:prstDash val="solid"/>
+          </a:ln>
+        </p:spPr>
+      </p:sp>
+      <p:sp>
+        <p:nvSpPr>
+          <p:cNvPr id="46" name="node-label-not_hired">
+            <a:extLst xmlns:a="http://schemas.openxmlformats.org/drawingml/2006/main">
+              <a:ext uri="{FF2B5EF4-FFF2-40B4-BE49-F238E27FC236}">
+                <a16:creationId xmlns:a16="http://schemas.microsoft.com/office/drawing/2014/main" id="{A95D0CBF-E044-40E5-B3D6-97FAB1FFB00C}"/>
+              </a:ext>
+            </a:extLst>
+          </p:cNvPr>
+          <p:cNvSpPr>
+            <a:spLocks xmlns:a="http://schemas.openxmlformats.org/drawingml/2006/main" noGrp="1"/>
+          </p:cNvSpPr>
+          <p:nvPr/>
+        </p:nvSpPr>
+        <p:spPr>
+          <a:xfrm xmlns:a="http://schemas.openxmlformats.org/drawingml/2006/main">
+            <a:off x="7639050" y="3234055"/>
+            <a:ext cx="1028700" cy="247650"/>
+          </a:xfrm>
+          <a:prstGeom xmlns:a="http://schemas.openxmlformats.org/drawingml/2006/main" prst="rect">
+            <a:avLst/>
+          </a:prstGeom>
+          <a:noFill xmlns:a="http://schemas.openxmlformats.org/drawingml/2006/main"/>
+          <a:ln xmlns:a="http://schemas.openxmlformats.org/drawingml/2006/main" w="0">
+            <a:noFill/>
             <a:prstDash val="solid"/>
           </a:ln>
         </p:spPr>
         <p:txBody>
-          <a:bodyPr xmlns:a="http://schemas.openxmlformats.org/drawingml/2006/main" anchor="ctr"/>
+          <a:bodyPr xmlns:a="http://schemas.openxmlformats.org/drawingml/2006/main" wrap="square" lIns="38100" tIns="19050" rIns="38100" bIns="19050" anchor="ctr">
+            <a:noAutofit/>
+          </a:bodyPr>
           <a:lstStyle xmlns:a="http://schemas.openxmlformats.org/drawingml/2006/main"/>
           <a:p xmlns:a="http://schemas.openxmlformats.org/drawingml/2006/main">
-            <a:pPr algn="ctr">
-              <a:defRPr sz="1600" b="1">
-                <a:solidFill>
-                  <a:srgbClr val="FFFFFF"/>
+            <a:pPr algn="l">
+              <a:defRPr sz="1200" b="1">
+                <a:solidFill>
+                  <a:srgbClr val="172033"/>
                 </a:solidFill>
               </a:defRPr>
             </a:pPr>
             <a:r>
-              <a:rPr sz="1600" b="1">
-                <a:solidFill>
-                  <a:srgbClr val="FFFFFF"/>
+              <a:rPr sz="1200" b="1">
+                <a:solidFill>
+                  <a:srgbClr val="172033"/>
                 </a:solidFill>
               </a:rPr>
               <a:t>未入职</a:t>
             </a:r>
           </a:p>
+        </p:txBody>
+      </p:sp>
+      <p:sp>
+        <p:nvSpPr>
+          <p:cNvPr id="47" name="node-value-not_hired">
+            <a:extLst xmlns:a="http://schemas.openxmlformats.org/drawingml/2006/main">
+              <a:ext uri="{FF2B5EF4-FFF2-40B4-BE49-F238E27FC236}">
+                <a16:creationId xmlns:a16="http://schemas.microsoft.com/office/drawing/2014/main" id="{69F5404B-EF58-4901-9DAD-DA7C4C042E88}"/>
+              </a:ext>
+            </a:extLst>
+          </p:cNvPr>
+          <p:cNvSpPr>
+            <a:spLocks xmlns:a="http://schemas.openxmlformats.org/drawingml/2006/main" noGrp="1"/>
+          </p:cNvSpPr>
+          <p:nvPr/>
+        </p:nvSpPr>
+        <p:spPr>
+          <a:xfrm xmlns:a="http://schemas.openxmlformats.org/drawingml/2006/main">
+            <a:off x="7639050" y="3491230"/>
+            <a:ext cx="1028700" cy="171450"/>
+          </a:xfrm>
+          <a:prstGeom xmlns:a="http://schemas.openxmlformats.org/drawingml/2006/main" prst="rect">
+            <a:avLst/>
+          </a:prstGeom>
+          <a:noFill xmlns:a="http://schemas.openxmlformats.org/drawingml/2006/main"/>
+          <a:ln xmlns:a="http://schemas.openxmlformats.org/drawingml/2006/main" w="0">
+            <a:noFill/>
+            <a:prstDash val="solid"/>
+          </a:ln>
+        </p:spPr>
+        <p:txBody>
+          <a:bodyPr xmlns:a="http://schemas.openxmlformats.org/drawingml/2006/main" wrap="none" lIns="38100" tIns="19050" rIns="38100" bIns="19050" anchor="ctr">
+            <a:noAutofit/>
+          </a:bodyPr>
+          <a:lstStyle xmlns:a="http://schemas.openxmlformats.org/drawingml/2006/main"/>
           <a:p xmlns:a="http://schemas.openxmlformats.org/drawingml/2006/main">
-            <a:pPr algn="ctr">
-              <a:defRPr sz="1600" b="1">
-                <a:solidFill>
-                  <a:srgbClr val="FFFFFF"/>
+            <a:pPr algn="l">
+              <a:defRPr sz="1200" b="0">
+                <a:solidFill>
+                  <a:srgbClr val="697386"/>
                 </a:solidFill>
               </a:defRPr>
             </a:pPr>
             <a:r>
-              <a:rPr sz="1600" b="1">
-                <a:solidFill>
-                  <a:srgbClr val="FFFFFF"/>
+              <a:rPr sz="1200" b="0">
+                <a:solidFill>
+                  <a:srgbClr val="697386"/>
                 </a:solidFill>
               </a:rPr>
               <a:t>560</a:t>
@@ -1999,68 +3390,132 @@
       </p:sp>
       <p:sp>
         <p:nvSpPr>
-          <p:cNvPr id="16" name="node-screened_out">
-            <a:extLst xmlns:a="http://schemas.openxmlformats.org/drawingml/2006/main">
-              <a:ext uri="{FF2B5EF4-FFF2-40B4-BE49-F238E27FC236}">
-                <a16:creationId xmlns:a16="http://schemas.microsoft.com/office/drawing/2014/main" id="{100E104D-52BB-45CA-8CD2-595A4C595C0D}"/>
-              </a:ext>
-            </a:extLst>
-          </p:cNvPr>
-          <p:cNvSpPr>
-            <a:spLocks xmlns:a="http://schemas.openxmlformats.org/drawingml/2006/main" noGrp="1"/>
-          </p:cNvSpPr>
-          <p:nvPr/>
-        </p:nvSpPr>
-        <p:spPr>
-          <a:xfrm xmlns:a="http://schemas.openxmlformats.org/drawingml/2006/main">
-            <a:off x="7239000" y="4382135"/>
-            <a:ext cx="1047750" cy="927100"/>
+          <p:cNvPr id="48" name="node-screened_out">
+            <a:extLst xmlns:a="http://schemas.openxmlformats.org/drawingml/2006/main">
+              <a:ext uri="{FF2B5EF4-FFF2-40B4-BE49-F238E27FC236}">
+                <a16:creationId xmlns:a16="http://schemas.microsoft.com/office/drawing/2014/main" id="{D072ED6F-2887-428E-A286-5C25DEFF2CC9}"/>
+              </a:ext>
+            </a:extLst>
+          </p:cNvPr>
+          <p:cNvSpPr>
+            <a:spLocks xmlns:a="http://schemas.openxmlformats.org/drawingml/2006/main" noGrp="1"/>
+          </p:cNvSpPr>
+          <p:nvPr/>
+        </p:nvSpPr>
+        <p:spPr>
+          <a:xfrm xmlns:a="http://schemas.openxmlformats.org/drawingml/2006/main">
+            <a:off x="7353300" y="4292600"/>
+            <a:ext cx="190500" cy="1022350"/>
           </a:xfrm>
           <a:prstGeom xmlns:a="http://schemas.openxmlformats.org/drawingml/2006/main" prst="rect">
             <a:avLst/>
           </a:prstGeom>
           <a:solidFill xmlns:a="http://schemas.openxmlformats.org/drawingml/2006/main">
-            <a:srgbClr val="E8872D"/>
-          </a:solidFill>
-          <a:ln xmlns:a="http://schemas.openxmlformats.org/drawingml/2006/main" w="9525">
-            <a:solidFill>
-              <a:srgbClr val="FFFFFF"/>
-            </a:solidFill>
+            <a:srgbClr val="D96F16"/>
+          </a:solidFill>
+          <a:ln xmlns:a="http://schemas.openxmlformats.org/drawingml/2006/main" w="0">
+            <a:noFill/>
+            <a:prstDash val="solid"/>
+          </a:ln>
+        </p:spPr>
+      </p:sp>
+      <p:sp>
+        <p:nvSpPr>
+          <p:cNvPr id="49" name="node-label-screened_out">
+            <a:extLst xmlns:a="http://schemas.openxmlformats.org/drawingml/2006/main">
+              <a:ext uri="{FF2B5EF4-FFF2-40B4-BE49-F238E27FC236}">
+                <a16:creationId xmlns:a16="http://schemas.microsoft.com/office/drawing/2014/main" id="{B0F1FE54-30E4-4654-822C-BB9D7540CA9B}"/>
+              </a:ext>
+            </a:extLst>
+          </p:cNvPr>
+          <p:cNvSpPr>
+            <a:spLocks xmlns:a="http://schemas.openxmlformats.org/drawingml/2006/main" noGrp="1"/>
+          </p:cNvSpPr>
+          <p:nvPr/>
+        </p:nvSpPr>
+        <p:spPr>
+          <a:xfrm xmlns:a="http://schemas.openxmlformats.org/drawingml/2006/main">
+            <a:off x="7639050" y="4594225"/>
+            <a:ext cx="1028700" cy="247650"/>
+          </a:xfrm>
+          <a:prstGeom xmlns:a="http://schemas.openxmlformats.org/drawingml/2006/main" prst="rect">
+            <a:avLst/>
+          </a:prstGeom>
+          <a:noFill xmlns:a="http://schemas.openxmlformats.org/drawingml/2006/main"/>
+          <a:ln xmlns:a="http://schemas.openxmlformats.org/drawingml/2006/main" w="0">
+            <a:noFill/>
             <a:prstDash val="solid"/>
           </a:ln>
         </p:spPr>
         <p:txBody>
-          <a:bodyPr xmlns:a="http://schemas.openxmlformats.org/drawingml/2006/main" anchor="ctr"/>
+          <a:bodyPr xmlns:a="http://schemas.openxmlformats.org/drawingml/2006/main" wrap="square" lIns="38100" tIns="19050" rIns="38100" bIns="19050" anchor="ctr">
+            <a:noAutofit/>
+          </a:bodyPr>
           <a:lstStyle xmlns:a="http://schemas.openxmlformats.org/drawingml/2006/main"/>
           <a:p xmlns:a="http://schemas.openxmlformats.org/drawingml/2006/main">
-            <a:pPr algn="ctr">
-              <a:defRPr sz="1600" b="1">
-                <a:solidFill>
-                  <a:srgbClr val="FFFFFF"/>
+            <a:pPr algn="l">
+              <a:defRPr sz="1200" b="1">
+                <a:solidFill>
+                  <a:srgbClr val="172033"/>
                 </a:solidFill>
               </a:defRPr>
             </a:pPr>
             <a:r>
-              <a:rPr sz="1600" b="1">
-                <a:solidFill>
-                  <a:srgbClr val="FFFFFF"/>
+              <a:rPr sz="1200" b="1">
+                <a:solidFill>
+                  <a:srgbClr val="172033"/>
                 </a:solidFill>
               </a:rPr>
               <a:t>已淘汰</a:t>
             </a:r>
           </a:p>
+        </p:txBody>
+      </p:sp>
+      <p:sp>
+        <p:nvSpPr>
+          <p:cNvPr id="50" name="node-value-screened_out">
+            <a:extLst xmlns:a="http://schemas.openxmlformats.org/drawingml/2006/main">
+              <a:ext uri="{FF2B5EF4-FFF2-40B4-BE49-F238E27FC236}">
+                <a16:creationId xmlns:a16="http://schemas.microsoft.com/office/drawing/2014/main" id="{B9484760-F41F-4603-8B27-C651C5B9B40F}"/>
+              </a:ext>
+            </a:extLst>
+          </p:cNvPr>
+          <p:cNvSpPr>
+            <a:spLocks xmlns:a="http://schemas.openxmlformats.org/drawingml/2006/main" noGrp="1"/>
+          </p:cNvSpPr>
+          <p:nvPr/>
+        </p:nvSpPr>
+        <p:spPr>
+          <a:xfrm xmlns:a="http://schemas.openxmlformats.org/drawingml/2006/main">
+            <a:off x="7639050" y="4851400"/>
+            <a:ext cx="1028700" cy="171450"/>
+          </a:xfrm>
+          <a:prstGeom xmlns:a="http://schemas.openxmlformats.org/drawingml/2006/main" prst="rect">
+            <a:avLst/>
+          </a:prstGeom>
+          <a:noFill xmlns:a="http://schemas.openxmlformats.org/drawingml/2006/main"/>
+          <a:ln xmlns:a="http://schemas.openxmlformats.org/drawingml/2006/main" w="0">
+            <a:noFill/>
+            <a:prstDash val="solid"/>
+          </a:ln>
+        </p:spPr>
+        <p:txBody>
+          <a:bodyPr xmlns:a="http://schemas.openxmlformats.org/drawingml/2006/main" wrap="none" lIns="38100" tIns="19050" rIns="38100" bIns="19050" anchor="ctr">
+            <a:noAutofit/>
+          </a:bodyPr>
+          <a:lstStyle xmlns:a="http://schemas.openxmlformats.org/drawingml/2006/main"/>
           <a:p xmlns:a="http://schemas.openxmlformats.org/drawingml/2006/main">
-            <a:pPr algn="ctr">
-              <a:defRPr sz="1600" b="1">
-                <a:solidFill>
-                  <a:srgbClr val="FFFFFF"/>
+            <a:pPr algn="l">
+              <a:defRPr sz="1200" b="0">
+                <a:solidFill>
+                  <a:srgbClr val="697386"/>
                 </a:solidFill>
               </a:defRPr>
             </a:pPr>
             <a:r>
-              <a:rPr sz="1600" b="1">
-                <a:solidFill>
-                  <a:srgbClr val="FFFFFF"/>
+              <a:rPr sz="1200" b="0">
+                <a:solidFill>
+                  <a:srgbClr val="697386"/>
                 </a:solidFill>
               </a:rPr>
               <a:t>400</a:t>
@@ -2070,93 +3525,10 @@
       </p:sp>
       <p:sp>
         <p:nvSpPr>
-          <p:cNvPr id="17" name="layer-4">
-            <a:extLst xmlns:a="http://schemas.openxmlformats.org/drawingml/2006/main">
-              <a:ext uri="{FF2B5EF4-FFF2-40B4-BE49-F238E27FC236}">
-                <a16:creationId xmlns:a16="http://schemas.microsoft.com/office/drawing/2014/main" id="{9437FEF4-3315-4670-963A-AF294F7E3502}"/>
-              </a:ext>
-            </a:extLst>
-          </p:cNvPr>
-          <p:cNvSpPr>
-            <a:spLocks xmlns:a="http://schemas.openxmlformats.org/drawingml/2006/main" noGrp="1"/>
-          </p:cNvSpPr>
-          <p:nvPr/>
-        </p:nvSpPr>
-        <p:spPr>
-          <a:xfrm xmlns:a="http://schemas.openxmlformats.org/drawingml/2006/main">
-            <a:off x="7239000" y="1352550"/>
-            <a:ext cx="1047750" cy="266700"/>
-          </a:xfrm>
-          <a:prstGeom xmlns:a="http://schemas.openxmlformats.org/drawingml/2006/main" prst="rect">
-            <a:avLst/>
-          </a:prstGeom>
-          <a:noFill xmlns:a="http://schemas.openxmlformats.org/drawingml/2006/main"/>
-          <a:ln xmlns:a="http://schemas.openxmlformats.org/drawingml/2006/main" w="0">
-            <a:noFill/>
-            <a:prstDash val="solid"/>
-          </a:ln>
-        </p:spPr>
-        <p:txBody>
-          <a:bodyPr xmlns:a="http://schemas.openxmlformats.org/drawingml/2006/main" anchor="ctr"/>
-          <a:lstStyle xmlns:a="http://schemas.openxmlformats.org/drawingml/2006/main"/>
-          <a:p xmlns:a="http://schemas.openxmlformats.org/drawingml/2006/main">
-            <a:pPr algn="ctr">
-              <a:defRPr sz="1600" b="1">
-                <a:solidFill>
-                  <a:srgbClr val="15375F"/>
-                </a:solidFill>
-              </a:defRPr>
-            </a:pPr>
-            <a:r>
-              <a:rPr sz="1600" b="1">
-                <a:solidFill>
-                  <a:srgbClr val="15375F"/>
-                </a:solidFill>
-              </a:rPr>
-              <a:t>12 个月状态｜留任率 25%</a:t>
-            </a:r>
-          </a:p>
-        </p:txBody>
-      </p:sp>
-      <p:sp>
-        <p:nvSpPr>
-          <p:cNvPr id="29" name="sankey-crossing-underpass-1">
-            <a:extLst xmlns:a="http://schemas.openxmlformats.org/drawingml/2006/main">
-              <a:ext uri="{FF2B5EF4-FFF2-40B4-BE49-F238E27FC236}">
-                <a16:creationId xmlns:a16="http://schemas.microsoft.com/office/drawing/2014/main" id="{9B2F4C4C-DD1D-4EB4-8C7C-6D6B2B97D194}"/>
-              </a:ext>
-            </a:extLst>
-          </p:cNvPr>
-          <p:cNvSpPr>
-            <a:spLocks xmlns:a="http://schemas.openxmlformats.org/drawingml/2006/main" noGrp="1"/>
-          </p:cNvSpPr>
-          <p:nvPr/>
-        </p:nvSpPr>
-        <p:spPr>
-          <a:xfrm xmlns:a="http://schemas.openxmlformats.org/drawingml/2006/main">
-            <a:off x="2362200" y="3552825"/>
-            <a:ext cx="133350" cy="133350"/>
-          </a:xfrm>
-          <a:prstGeom xmlns:a="http://schemas.openxmlformats.org/drawingml/2006/main" prst="ellipse">
-            <a:avLst/>
-          </a:prstGeom>
-          <a:solidFill xmlns:a="http://schemas.openxmlformats.org/drawingml/2006/main">
-            <a:srgbClr val="FFFFFF"/>
-          </a:solidFill>
-          <a:ln xmlns:a="http://schemas.openxmlformats.org/drawingml/2006/main" w="0">
-            <a:solidFill>
-              <a:srgbClr val="FFFFFF"/>
-            </a:solidFill>
-            <a:prstDash val="solid"/>
-          </a:ln>
-        </p:spPr>
-      </p:sp>
-      <p:sp>
-        <p:nvSpPr>
-          <p:cNvPr id="31" name="关键洞察-rail">
-            <a:extLst xmlns:a="http://schemas.openxmlformats.org/drawingml/2006/main">
-              <a:ext uri="{FF2B5EF4-FFF2-40B4-BE49-F238E27FC236}">
-                <a16:creationId xmlns:a16="http://schemas.microsoft.com/office/drawing/2014/main" id="{AF5F3E29-8799-4CF4-81E3-DD18D6E3E60C}"/>
+          <p:cNvPr id="51" name="关键洞察-rail">
+            <a:extLst xmlns:a="http://schemas.openxmlformats.org/drawingml/2006/main">
+              <a:ext uri="{FF2B5EF4-FFF2-40B4-BE49-F238E27FC236}">
+                <a16:creationId xmlns:a16="http://schemas.microsoft.com/office/drawing/2014/main" id="{84CE7B83-0968-4900-92C2-AC56368BA9C6}"/>
               </a:ext>
             </a:extLst>
           </p:cNvPr>
@@ -2170,10 +3542,8 @@
             <a:off x="8896350" y="1200150"/>
             <a:ext cx="2781300" cy="4438650"/>
           </a:xfrm>
-          <a:prstGeom xmlns:a="http://schemas.openxmlformats.org/drawingml/2006/main" prst="roundRect">
-            <a:avLst>
-              <a:gd name="adj" fmla="val 2740"/>
-            </a:avLst>
+          <a:prstGeom xmlns:a="http://schemas.openxmlformats.org/drawingml/2006/main" prst="rect">
+            <a:avLst/>
           </a:prstGeom>
           <a:solidFill xmlns:a="http://schemas.openxmlformats.org/drawingml/2006/main">
             <a:srgbClr val="F4F6F8"/>
@@ -2188,10 +3558,10 @@
       </p:sp>
       <p:sp>
         <p:nvSpPr>
-          <p:cNvPr id="32" name="关键洞察-title">
-            <a:extLst xmlns:a="http://schemas.openxmlformats.org/drawingml/2006/main">
-              <a:ext uri="{FF2B5EF4-FFF2-40B4-BE49-F238E27FC236}">
-                <a16:creationId xmlns:a16="http://schemas.microsoft.com/office/drawing/2014/main" id="{327AB745-5A19-40FF-88BE-5E5DE0BECBC0}"/>
+          <p:cNvPr id="52" name="关键洞察-title">
+            <a:extLst xmlns:a="http://schemas.openxmlformats.org/drawingml/2006/main">
+              <a:ext uri="{FF2B5EF4-FFF2-40B4-BE49-F238E27FC236}">
+                <a16:creationId xmlns:a16="http://schemas.microsoft.com/office/drawing/2014/main" id="{B08C3B65-B9C4-4EDD-8FAE-67BB96EC0CA3}"/>
               </a:ext>
             </a:extLst>
           </p:cNvPr>
@@ -2215,18 +3585,20 @@
           </a:ln>
         </p:spPr>
         <p:txBody>
-          <a:bodyPr xmlns:a="http://schemas.openxmlformats.org/drawingml/2006/main" anchor="ctr"/>
+          <a:bodyPr xmlns:a="http://schemas.openxmlformats.org/drawingml/2006/main" wrap="square" lIns="38100" tIns="19050" rIns="38100" bIns="19050" anchor="ctr">
+            <a:noAutofit/>
+          </a:bodyPr>
           <a:lstStyle xmlns:a="http://schemas.openxmlformats.org/drawingml/2006/main"/>
           <a:p xmlns:a="http://schemas.openxmlformats.org/drawingml/2006/main">
             <a:pPr algn="l">
-              <a:defRPr sz="1600" b="1">
+              <a:defRPr sz="1800" b="1">
                 <a:solidFill>
                   <a:srgbClr val="15375F"/>
                 </a:solidFill>
               </a:defRPr>
             </a:pPr>
             <a:r>
-              <a:rPr sz="1600" b="1">
+              <a:rPr sz="1800" b="1">
                 <a:solidFill>
                   <a:srgbClr val="15375F"/>
                 </a:solidFill>
@@ -2238,10 +3610,10 @@
       </p:sp>
       <p:sp>
         <p:nvSpPr>
-          <p:cNvPr id="33" name="关键洞察-1">
-            <a:extLst xmlns:a="http://schemas.openxmlformats.org/drawingml/2006/main">
-              <a:ext uri="{FF2B5EF4-FFF2-40B4-BE49-F238E27FC236}">
-                <a16:creationId xmlns:a16="http://schemas.microsoft.com/office/drawing/2014/main" id="{31BA6EC3-8960-48E6-A97F-E1C4A5CDFB6D}"/>
+          <p:cNvPr id="53" name="关键洞察-1">
+            <a:extLst xmlns:a="http://schemas.openxmlformats.org/drawingml/2006/main">
+              <a:ext uri="{FF2B5EF4-FFF2-40B4-BE49-F238E27FC236}">
+                <a16:creationId xmlns:a16="http://schemas.microsoft.com/office/drawing/2014/main" id="{D45A3FE8-DEED-45A3-A4AE-E8ECFC42F3D2}"/>
               </a:ext>
             </a:extLst>
           </p:cNvPr>
@@ -2255,10 +3627,8 @@
             <a:off x="9048750" y="1771650"/>
             <a:ext cx="2476500" cy="914400"/>
           </a:xfrm>
-          <a:prstGeom xmlns:a="http://schemas.openxmlformats.org/drawingml/2006/main" prst="roundRect">
-            <a:avLst>
-              <a:gd name="adj" fmla="val 8333"/>
-            </a:avLst>
+          <a:prstGeom xmlns:a="http://schemas.openxmlformats.org/drawingml/2006/main" prst="rect">
+            <a:avLst/>
           </a:prstGeom>
           <a:solidFill xmlns:a="http://schemas.openxmlformats.org/drawingml/2006/main">
             <a:srgbClr val="FFFFFF"/>
@@ -2271,7 +3641,9 @@
           </a:ln>
         </p:spPr>
         <p:txBody>
-          <a:bodyPr xmlns:a="http://schemas.openxmlformats.org/drawingml/2006/main" anchor="ctr"/>
+          <a:bodyPr xmlns:a="http://schemas.openxmlformats.org/drawingml/2006/main" wrap="square" lIns="38100" tIns="19050" rIns="38100" bIns="19050" anchor="ctr">
+            <a:noAutofit/>
+          </a:bodyPr>
           <a:lstStyle xmlns:a="http://schemas.openxmlformats.org/drawingml/2006/main"/>
           <a:p xmlns:a="http://schemas.openxmlformats.org/drawingml/2006/main">
             <a:pPr algn="l">
@@ -2287,17 +3659,17 @@
                   <a:srgbClr val="172033"/>
                 </a:solidFill>
               </a:rPr>
-              <a:t>已入职人群 12 个月流失 180 人</a:t>
+              <a:t>已入职人群 12个月流失 180人</a:t>
             </a:r>
           </a:p>
         </p:txBody>
       </p:sp>
       <p:sp>
         <p:nvSpPr>
-          <p:cNvPr id="34" name="关键洞察-2">
-            <a:extLst xmlns:a="http://schemas.openxmlformats.org/drawingml/2006/main">
-              <a:ext uri="{FF2B5EF4-FFF2-40B4-BE49-F238E27FC236}">
-                <a16:creationId xmlns:a16="http://schemas.microsoft.com/office/drawing/2014/main" id="{7D7E5576-0D46-4327-8A72-3EAF9FAC6AC7}"/>
+          <p:cNvPr id="54" name="关键洞察-2">
+            <a:extLst xmlns:a="http://schemas.openxmlformats.org/drawingml/2006/main">
+              <a:ext uri="{FF2B5EF4-FFF2-40B4-BE49-F238E27FC236}">
+                <a16:creationId xmlns:a16="http://schemas.microsoft.com/office/drawing/2014/main" id="{6E606558-1072-44E6-9F16-BFBFF02E5ED6}"/>
               </a:ext>
             </a:extLst>
           </p:cNvPr>
@@ -2311,10 +3683,8 @@
             <a:off x="9048750" y="2933700"/>
             <a:ext cx="2476500" cy="914400"/>
           </a:xfrm>
-          <a:prstGeom xmlns:a="http://schemas.openxmlformats.org/drawingml/2006/main" prst="roundRect">
-            <a:avLst>
-              <a:gd name="adj" fmla="val 8333"/>
-            </a:avLst>
+          <a:prstGeom xmlns:a="http://schemas.openxmlformats.org/drawingml/2006/main" prst="rect">
+            <a:avLst/>
           </a:prstGeom>
           <a:solidFill xmlns:a="http://schemas.openxmlformats.org/drawingml/2006/main">
             <a:srgbClr val="FFFFFF"/>
@@ -2327,7 +3697,9 @@
           </a:ln>
         </p:spPr>
         <p:txBody>
-          <a:bodyPr xmlns:a="http://schemas.openxmlformats.org/drawingml/2006/main" anchor="ctr"/>
+          <a:bodyPr xmlns:a="http://schemas.openxmlformats.org/drawingml/2006/main" wrap="square" lIns="38100" tIns="19050" rIns="38100" bIns="19050" anchor="ctr">
+            <a:noAutofit/>
+          </a:bodyPr>
           <a:lstStyle xmlns:a="http://schemas.openxmlformats.org/drawingml/2006/main"/>
           <a:p xmlns:a="http://schemas.openxmlformats.org/drawingml/2006/main">
             <a:pPr algn="l">
@@ -2343,17 +3715,17 @@
                   <a:srgbClr val="172033"/>
                 </a:solidFill>
               </a:rPr>
-              <a:t>筛选通过后仍有 560 人未入职</a:t>
+              <a:t>筛选通过后仍有 560人未入职</a:t>
             </a:r>
           </a:p>
         </p:txBody>
       </p:sp>
       <p:sp>
         <p:nvSpPr>
-          <p:cNvPr id="35" name="关键洞察-3">
-            <a:extLst xmlns:a="http://schemas.openxmlformats.org/drawingml/2006/main">
-              <a:ext uri="{FF2B5EF4-FFF2-40B4-BE49-F238E27FC236}">
-                <a16:creationId xmlns:a16="http://schemas.microsoft.com/office/drawing/2014/main" id="{F201E9EC-0C81-4437-BA7A-25A239BCFECA}"/>
+          <p:cNvPr id="55" name="关键洞察-3">
+            <a:extLst xmlns:a="http://schemas.openxmlformats.org/drawingml/2006/main">
+              <a:ext uri="{FF2B5EF4-FFF2-40B4-BE49-F238E27FC236}">
+                <a16:creationId xmlns:a16="http://schemas.microsoft.com/office/drawing/2014/main" id="{97240FEC-D8ED-4338-9B86-E8F557B0E2C2}"/>
               </a:ext>
             </a:extLst>
           </p:cNvPr>
@@ -2367,10 +3739,8 @@
             <a:off x="9048750" y="4095750"/>
             <a:ext cx="2476500" cy="914400"/>
           </a:xfrm>
-          <a:prstGeom xmlns:a="http://schemas.openxmlformats.org/drawingml/2006/main" prst="roundRect">
-            <a:avLst>
-              <a:gd name="adj" fmla="val 8333"/>
-            </a:avLst>
+          <a:prstGeom xmlns:a="http://schemas.openxmlformats.org/drawingml/2006/main" prst="rect">
+            <a:avLst/>
           </a:prstGeom>
           <a:solidFill xmlns:a="http://schemas.openxmlformats.org/drawingml/2006/main">
             <a:srgbClr val="FFFFFF"/>
@@ -2383,7 +3753,9 @@
           </a:ln>
         </p:spPr>
         <p:txBody>
-          <a:bodyPr xmlns:a="http://schemas.openxmlformats.org/drawingml/2006/main" anchor="ctr"/>
+          <a:bodyPr xmlns:a="http://schemas.openxmlformats.org/drawingml/2006/main" wrap="square" lIns="38100" tIns="19050" rIns="38100" bIns="19050" anchor="ctr">
+            <a:noAutofit/>
+          </a:bodyPr>
           <a:lstStyle xmlns:a="http://schemas.openxmlformats.org/drawingml/2006/main"/>
           <a:p xmlns:a="http://schemas.openxmlformats.org/drawingml/2006/main">
             <a:pPr algn="l">
@@ -2406,10 +3778,10 @@
       </p:sp>
       <p:sp>
         <p:nvSpPr>
-          <p:cNvPr id="39" name="bottom">
-            <a:extLst xmlns:a="http://schemas.openxmlformats.org/drawingml/2006/main">
-              <a:ext uri="{FF2B5EF4-FFF2-40B4-BE49-F238E27FC236}">
-                <a16:creationId xmlns:a16="http://schemas.microsoft.com/office/drawing/2014/main" id="{39AB5F6F-893F-4180-9F47-E319589D960B}"/>
+          <p:cNvPr id="59" name="bottom">
+            <a:extLst xmlns:a="http://schemas.openxmlformats.org/drawingml/2006/main">
+              <a:ext uri="{FF2B5EF4-FFF2-40B4-BE49-F238E27FC236}">
+                <a16:creationId xmlns:a16="http://schemas.microsoft.com/office/drawing/2014/main" id="{0290D07C-E6DF-493E-A785-4026B4C8F676}"/>
               </a:ext>
             </a:extLst>
           </p:cNvPr>
@@ -2423,10 +3795,8 @@
             <a:off x="514350" y="5905500"/>
             <a:ext cx="11163300" cy="419100"/>
           </a:xfrm>
-          <a:prstGeom xmlns:a="http://schemas.openxmlformats.org/drawingml/2006/main" prst="roundRect">
-            <a:avLst>
-              <a:gd name="adj" fmla="val 18182"/>
-            </a:avLst>
+          <a:prstGeom xmlns:a="http://schemas.openxmlformats.org/drawingml/2006/main" prst="rect">
+            <a:avLst/>
           </a:prstGeom>
           <a:solidFill xmlns:a="http://schemas.openxmlformats.org/drawingml/2006/main">
             <a:srgbClr val="FFF0E2"/>
@@ -2439,340 +3809,42 @@
           </a:ln>
         </p:spPr>
         <p:txBody>
-          <a:bodyPr xmlns:a="http://schemas.openxmlformats.org/drawingml/2006/main" anchor="ctr"/>
+          <a:bodyPr xmlns:a="http://schemas.openxmlformats.org/drawingml/2006/main" wrap="square" lIns="38100" tIns="19050" rIns="38100" bIns="19050" anchor="ctr">
+            <a:noAutofit/>
+          </a:bodyPr>
           <a:lstStyle xmlns:a="http://schemas.openxmlformats.org/drawingml/2006/main"/>
           <a:p xmlns:a="http://schemas.openxmlformats.org/drawingml/2006/main">
             <a:pPr algn="ctr">
-              <a:defRPr sz="1600" b="1">
+              <a:defRPr sz="1800" b="1">
                 <a:solidFill>
                   <a:srgbClr val="15375F"/>
                 </a:solidFill>
               </a:defRPr>
             </a:pPr>
             <a:r>
-              <a:rPr sz="1600" b="1">
+              <a:rPr sz="1800" b="1">
                 <a:solidFill>
                   <a:srgbClr val="15375F"/>
                 </a:solidFill>
               </a:rPr>
-              <a:t>先改善入职转化与 12 个月留任，预计每年新增留任 95 人</a:t>
+              <a:t>先改善入职转化与 12个月留任，预计每年新增留任 95人</a:t>
             </a:r>
           </a:p>
         </p:txBody>
       </p:sp>
       <p:cxnSp>
         <p:nvCxnSpPr>
-          <p:cNvPr id="64" name=""/>
+          <p:cNvPr id="116" name=""/>
           <p:cNvCxnSpPr>
-            <a:stCxn xmlns:a="http://schemas.openxmlformats.org/drawingml/2006/main" id="6" idx="3"/>
-            <a:endCxn xmlns:a="http://schemas.openxmlformats.org/drawingml/2006/main" id="10" idx="1"/>
+            <a:stCxn xmlns:a="http://schemas.openxmlformats.org/drawingml/2006/main" id="42" idx="3"/>
+            <a:endCxn xmlns:a="http://schemas.openxmlformats.org/drawingml/2006/main" id="53" idx="1"/>
           </p:cNvCxnSpPr>
           <p:nvPr/>
         </p:nvCxnSpPr>
         <p:spPr>
-          <a:xfrm xmlns:a="http://schemas.openxmlformats.org/drawingml/2006/main">
-            <a:off x="4019550" y="2781300"/>
-            <a:ext cx="1085850" cy="438785"/>
-          </a:xfrm>
-          <a:prstGeom xmlns:a="http://schemas.openxmlformats.org/drawingml/2006/main" prst="straightConnector1">
-            <a:avLst/>
-          </a:prstGeom>
-          <a:ln xmlns:a="http://schemas.openxmlformats.org/drawingml/2006/main" w="76200">
-            <a:solidFill>
-              <a:srgbClr val="E8872D"/>
-            </a:solidFill>
-            <a:prstDash val="dash"/>
-          </a:ln>
-        </p:spPr>
-      </p:cxnSp>
-      <p:cxnSp>
-        <p:nvCxnSpPr>
-          <p:cNvPr id="65" name=""/>
-          <p:cNvCxnSpPr>
-            <a:stCxn xmlns:a="http://schemas.openxmlformats.org/drawingml/2006/main" id="10" idx="3"/>
-            <a:endCxn xmlns:a="http://schemas.openxmlformats.org/drawingml/2006/main" id="15" idx="1"/>
-          </p:cNvCxnSpPr>
-          <p:nvPr/>
-        </p:nvCxnSpPr>
-        <p:spPr>
-          <a:xfrm xmlns:a="http://schemas.openxmlformats.org/drawingml/2006/main">
-            <a:off x="6153150" y="3220085"/>
-            <a:ext cx="1085850" cy="303530"/>
-          </a:xfrm>
-          <a:prstGeom xmlns:a="http://schemas.openxmlformats.org/drawingml/2006/main" prst="straightConnector1">
-            <a:avLst/>
-          </a:prstGeom>
-          <a:ln xmlns:a="http://schemas.openxmlformats.org/drawingml/2006/main" w="76200">
-            <a:solidFill>
-              <a:srgbClr val="E8872D"/>
-            </a:solidFill>
-            <a:prstDash val="dash"/>
-          </a:ln>
-        </p:spPr>
-      </p:cxnSp>
-      <p:cxnSp>
-        <p:nvCxnSpPr>
-          <p:cNvPr id="66" name=""/>
-          <p:cNvCxnSpPr>
-            <a:stCxn xmlns:a="http://schemas.openxmlformats.org/drawingml/2006/main" id="3" idx="3"/>
-            <a:endCxn xmlns:a="http://schemas.openxmlformats.org/drawingml/2006/main" id="6" idx="1"/>
-          </p:cNvCxnSpPr>
-          <p:nvPr/>
-        </p:nvCxnSpPr>
-        <p:spPr>
-          <a:xfrm xmlns:a="http://schemas.openxmlformats.org/drawingml/2006/main">
-            <a:off x="1885950" y="2647950"/>
-            <a:ext cx="1085850" cy="133350"/>
-          </a:xfrm>
-          <a:prstGeom xmlns:a="http://schemas.openxmlformats.org/drawingml/2006/main" prst="straightConnector1">
-            <a:avLst/>
-          </a:prstGeom>
-          <a:ln xmlns:a="http://schemas.openxmlformats.org/drawingml/2006/main" w="63954">
-            <a:solidFill>
-              <a:srgbClr val="2F6FB2"/>
-            </a:solidFill>
-            <a:prstDash val="solid"/>
-          </a:ln>
-        </p:spPr>
-      </p:cxnSp>
-      <p:cxnSp>
-        <p:nvCxnSpPr>
-          <p:cNvPr id="67" name=""/>
-          <p:cNvCxnSpPr>
-            <a:stCxn xmlns:a="http://schemas.openxmlformats.org/drawingml/2006/main" id="7" idx="3"/>
-            <a:endCxn xmlns:a="http://schemas.openxmlformats.org/drawingml/2006/main" id="11" idx="1"/>
-          </p:cNvCxnSpPr>
-          <p:nvPr/>
-        </p:nvCxnSpPr>
-        <p:spPr>
-          <a:xfrm xmlns:a="http://schemas.openxmlformats.org/drawingml/2006/main">
-            <a:off x="4019550" y="4591050"/>
-            <a:ext cx="1085850" cy="34925"/>
-          </a:xfrm>
-          <a:prstGeom xmlns:a="http://schemas.openxmlformats.org/drawingml/2006/main" prst="straightConnector1">
-            <a:avLst/>
-          </a:prstGeom>
-          <a:ln xmlns:a="http://schemas.openxmlformats.org/drawingml/2006/main" w="54429">
-            <a:solidFill>
-              <a:srgbClr val="E8872D"/>
-            </a:solidFill>
-            <a:prstDash val="dash"/>
-          </a:ln>
-        </p:spPr>
-      </p:cxnSp>
-      <p:cxnSp>
-        <p:nvCxnSpPr>
-          <p:cNvPr id="68" name=""/>
-          <p:cNvCxnSpPr>
-            <a:stCxn xmlns:a="http://schemas.openxmlformats.org/drawingml/2006/main" id="11" idx="3"/>
-            <a:endCxn xmlns:a="http://schemas.openxmlformats.org/drawingml/2006/main" id="16" idx="1"/>
-          </p:cNvCxnSpPr>
-          <p:nvPr/>
-        </p:nvCxnSpPr>
-        <p:spPr>
-          <a:xfrm xmlns:a="http://schemas.openxmlformats.org/drawingml/2006/main">
-            <a:off x="6153150" y="4625975"/>
-            <a:ext cx="1085850" cy="219710"/>
-          </a:xfrm>
-          <a:prstGeom xmlns:a="http://schemas.openxmlformats.org/drawingml/2006/main" prst="straightConnector1">
-            <a:avLst/>
-          </a:prstGeom>
-          <a:ln xmlns:a="http://schemas.openxmlformats.org/drawingml/2006/main" w="54429">
-            <a:solidFill>
-              <a:srgbClr val="E8872D"/>
-            </a:solidFill>
-            <a:prstDash val="dash"/>
-          </a:ln>
-        </p:spPr>
-      </p:cxnSp>
-      <p:cxnSp>
-        <p:nvCxnSpPr>
-          <p:cNvPr id="69" name=""/>
-          <p:cNvCxnSpPr>
-            <a:stCxn xmlns:a="http://schemas.openxmlformats.org/drawingml/2006/main" id="4" idx="3"/>
-            <a:endCxn xmlns:a="http://schemas.openxmlformats.org/drawingml/2006/main" id="6" idx="1"/>
-          </p:cNvCxnSpPr>
-          <p:nvPr/>
-        </p:nvCxnSpPr>
-        <p:spPr>
           <a:xfrm xmlns:a="http://schemas.openxmlformats.org/drawingml/2006/main" flipV="1">
-            <a:off x="1885950" y="2781300"/>
-            <a:ext cx="1085850" cy="1676400"/>
-          </a:xfrm>
-          <a:prstGeom xmlns:a="http://schemas.openxmlformats.org/drawingml/2006/main" prst="straightConnector1">
-            <a:avLst/>
-          </a:prstGeom>
-          <a:ln xmlns:a="http://schemas.openxmlformats.org/drawingml/2006/main" w="44904">
-            <a:solidFill>
-              <a:srgbClr val="2F6FB2"/>
-            </a:solidFill>
-            <a:prstDash val="solid"/>
-          </a:ln>
-        </p:spPr>
-      </p:cxnSp>
-      <p:cxnSp>
-        <p:nvCxnSpPr>
-          <p:cNvPr id="70" name=""/>
-          <p:cNvCxnSpPr>
-            <a:stCxn xmlns:a="http://schemas.openxmlformats.org/drawingml/2006/main" id="6" idx="3"/>
-            <a:endCxn xmlns:a="http://schemas.openxmlformats.org/drawingml/2006/main" id="9" idx="1"/>
-          </p:cNvCxnSpPr>
-          <p:nvPr/>
-        </p:nvCxnSpPr>
-        <p:spPr>
-          <a:xfrm xmlns:a="http://schemas.openxmlformats.org/drawingml/2006/main" flipV="1">
-            <a:off x="4019550" y="2013585"/>
-            <a:ext cx="1085850" cy="767715"/>
-          </a:xfrm>
-          <a:prstGeom xmlns:a="http://schemas.openxmlformats.org/drawingml/2006/main" prst="straightConnector1">
-            <a:avLst/>
-          </a:prstGeom>
-          <a:ln xmlns:a="http://schemas.openxmlformats.org/drawingml/2006/main" w="32657">
-            <a:solidFill>
-              <a:srgbClr val="2F6FB2"/>
-            </a:solidFill>
-            <a:prstDash val="solid"/>
-          </a:ln>
-        </p:spPr>
-      </p:cxnSp>
-      <p:cxnSp>
-        <p:nvCxnSpPr>
-          <p:cNvPr id="71" name=""/>
-          <p:cNvCxnSpPr>
-            <a:stCxn xmlns:a="http://schemas.openxmlformats.org/drawingml/2006/main" id="3" idx="3"/>
-            <a:endCxn xmlns:a="http://schemas.openxmlformats.org/drawingml/2006/main" id="7" idx="1"/>
-          </p:cNvCxnSpPr>
-          <p:nvPr/>
-        </p:nvCxnSpPr>
-        <p:spPr>
-          <a:xfrm xmlns:a="http://schemas.openxmlformats.org/drawingml/2006/main">
-            <a:off x="1885950" y="2647950"/>
-            <a:ext cx="1085850" cy="1943100"/>
-          </a:xfrm>
-          <a:prstGeom xmlns:a="http://schemas.openxmlformats.org/drawingml/2006/main" prst="straightConnector1">
-            <a:avLst/>
-          </a:prstGeom>
-          <a:ln xmlns:a="http://schemas.openxmlformats.org/drawingml/2006/main" w="31296">
-            <a:solidFill>
-              <a:srgbClr val="E8872D"/>
-            </a:solidFill>
-            <a:prstDash val="dash"/>
-          </a:ln>
-        </p:spPr>
-      </p:cxnSp>
-      <p:cxnSp>
-        <p:nvCxnSpPr>
-          <p:cNvPr id="72" name=""/>
-          <p:cNvCxnSpPr>
-            <a:stCxn xmlns:a="http://schemas.openxmlformats.org/drawingml/2006/main" id="9" idx="3"/>
-            <a:endCxn xmlns:a="http://schemas.openxmlformats.org/drawingml/2006/main" id="14" idx="1"/>
-          </p:cNvCxnSpPr>
-          <p:nvPr/>
-        </p:nvCxnSpPr>
-        <p:spPr>
-          <a:xfrm xmlns:a="http://schemas.openxmlformats.org/drawingml/2006/main">
-            <a:off x="6153150" y="2013585"/>
-            <a:ext cx="1085850" cy="442912"/>
-          </a:xfrm>
-          <a:prstGeom xmlns:a="http://schemas.openxmlformats.org/drawingml/2006/main" prst="straightConnector1">
-            <a:avLst/>
-          </a:prstGeom>
-          <a:ln xmlns:a="http://schemas.openxmlformats.org/drawingml/2006/main" w="24493">
-            <a:solidFill>
-              <a:srgbClr val="E8872D"/>
-            </a:solidFill>
-            <a:prstDash val="dash"/>
-          </a:ln>
-        </p:spPr>
-      </p:cxnSp>
-      <p:cxnSp>
-        <p:nvCxnSpPr>
-          <p:cNvPr id="73" name=""/>
-          <p:cNvCxnSpPr>
-            <a:stCxn xmlns:a="http://schemas.openxmlformats.org/drawingml/2006/main" id="4" idx="3"/>
-            <a:endCxn xmlns:a="http://schemas.openxmlformats.org/drawingml/2006/main" id="7" idx="1"/>
-          </p:cNvCxnSpPr>
-          <p:nvPr/>
-        </p:nvCxnSpPr>
-        <p:spPr>
-          <a:xfrm xmlns:a="http://schemas.openxmlformats.org/drawingml/2006/main">
-            <a:off x="1885950" y="4457700"/>
-            <a:ext cx="1085850" cy="133350"/>
-          </a:xfrm>
-          <a:prstGeom xmlns:a="http://schemas.openxmlformats.org/drawingml/2006/main" prst="straightConnector1">
-            <a:avLst/>
-          </a:prstGeom>
-          <a:ln xmlns:a="http://schemas.openxmlformats.org/drawingml/2006/main" w="23132">
-            <a:solidFill>
-              <a:srgbClr val="E8872D"/>
-            </a:solidFill>
-            <a:prstDash val="dash"/>
-          </a:ln>
-        </p:spPr>
-      </p:cxnSp>
-      <p:cxnSp>
-        <p:nvCxnSpPr>
-          <p:cNvPr id="74" name=""/>
-          <p:cNvCxnSpPr>
-            <a:stCxn xmlns:a="http://schemas.openxmlformats.org/drawingml/2006/main" id="9" idx="3"/>
-            <a:endCxn xmlns:a="http://schemas.openxmlformats.org/drawingml/2006/main" id="13" idx="1"/>
-          </p:cNvCxnSpPr>
-          <p:nvPr/>
-        </p:nvCxnSpPr>
-        <p:spPr>
-          <a:xfrm xmlns:a="http://schemas.openxmlformats.org/drawingml/2006/main" flipV="1">
-            <a:off x="6153150" y="1876425"/>
-            <a:ext cx="1085850" cy="137160"/>
-          </a:xfrm>
-          <a:prstGeom xmlns:a="http://schemas.openxmlformats.org/drawingml/2006/main" prst="straightConnector1">
-            <a:avLst/>
-          </a:prstGeom>
-          <a:ln xmlns:a="http://schemas.openxmlformats.org/drawingml/2006/main" w="14288">
-            <a:solidFill>
-              <a:srgbClr val="2F6FB2"/>
-            </a:solidFill>
-            <a:prstDash val="solid"/>
-          </a:ln>
-        </p:spPr>
-      </p:cxnSp>
-      <p:cxnSp>
-        <p:nvCxnSpPr>
-          <p:cNvPr id="75" name=""/>
-          <p:cNvCxnSpPr>
-            <a:stCxn xmlns:a="http://schemas.openxmlformats.org/drawingml/2006/main" id="4" idx="3"/>
-            <a:endCxn xmlns:a="http://schemas.openxmlformats.org/drawingml/2006/main" id="6" idx="1"/>
-          </p:cNvCxnSpPr>
-          <p:nvPr/>
-        </p:nvCxnSpPr>
-        <p:spPr>
-          <a:xfrm xmlns:a="http://schemas.openxmlformats.org/drawingml/2006/main" flipV="1">
-            <a:off x="1885950" y="2781300"/>
-            <a:ext cx="1085850" cy="1676400"/>
-          </a:xfrm>
-          <a:prstGeom xmlns:a="http://schemas.openxmlformats.org/drawingml/2006/main" prst="straightConnector1">
-            <a:avLst/>
-          </a:prstGeom>
-          <a:ln xmlns:a="http://schemas.openxmlformats.org/drawingml/2006/main" w="44904">
-            <a:solidFill>
-              <a:srgbClr val="2F6FB2"/>
-            </a:solidFill>
-            <a:prstDash val="solid"/>
-          </a:ln>
-        </p:spPr>
-      </p:cxnSp>
-      <p:cxnSp>
-        <p:nvCxnSpPr>
-          <p:cNvPr id="76" name=""/>
-          <p:cNvCxnSpPr>
-            <a:stCxn xmlns:a="http://schemas.openxmlformats.org/drawingml/2006/main" id="14" idx="3"/>
-            <a:endCxn xmlns:a="http://schemas.openxmlformats.org/drawingml/2006/main" id="33" idx="1"/>
-          </p:cNvCxnSpPr>
-          <p:nvPr/>
-        </p:nvCxnSpPr>
-        <p:spPr>
-          <a:xfrm xmlns:a="http://schemas.openxmlformats.org/drawingml/2006/main" flipV="1">
-            <a:off x="8286750" y="2228850"/>
-            <a:ext cx="762000" cy="227647"/>
+            <a:off x="7543800" y="2228850"/>
+            <a:ext cx="1504950" cy="135732"/>
           </a:xfrm>
           <a:prstGeom xmlns:a="http://schemas.openxmlformats.org/drawingml/2006/main" prst="bentConnector3">
             <a:avLst>
@@ -2789,17 +3861,17 @@
       </p:cxnSp>
       <p:cxnSp>
         <p:nvCxnSpPr>
-          <p:cNvPr id="77" name=""/>
+          <p:cNvPr id="117" name=""/>
           <p:cNvCxnSpPr>
-            <a:stCxn xmlns:a="http://schemas.openxmlformats.org/drawingml/2006/main" id="15" idx="3"/>
-            <a:endCxn xmlns:a="http://schemas.openxmlformats.org/drawingml/2006/main" id="34" idx="1"/>
+            <a:stCxn xmlns:a="http://schemas.openxmlformats.org/drawingml/2006/main" id="45" idx="3"/>
+            <a:endCxn xmlns:a="http://schemas.openxmlformats.org/drawingml/2006/main" id="54" idx="1"/>
           </p:cNvCxnSpPr>
           <p:nvPr/>
         </p:nvCxnSpPr>
         <p:spPr>
           <a:xfrm xmlns:a="http://schemas.openxmlformats.org/drawingml/2006/main" flipV="1">
-            <a:off x="8286750" y="3390900"/>
-            <a:ext cx="762000" cy="132715"/>
+            <a:off x="7543800" y="3390900"/>
+            <a:ext cx="1504950" cy="52705"/>
           </a:xfrm>
           <a:prstGeom xmlns:a="http://schemas.openxmlformats.org/drawingml/2006/main" prst="bentConnector3">
             <a:avLst>
@@ -2816,17 +3888,17 @@
       </p:cxnSp>
       <p:cxnSp>
         <p:nvCxnSpPr>
-          <p:cNvPr id="78" name=""/>
+          <p:cNvPr id="118" name=""/>
           <p:cNvCxnSpPr>
-            <a:stCxn xmlns:a="http://schemas.openxmlformats.org/drawingml/2006/main" id="16" idx="3"/>
-            <a:endCxn xmlns:a="http://schemas.openxmlformats.org/drawingml/2006/main" id="35" idx="1"/>
+            <a:stCxn xmlns:a="http://schemas.openxmlformats.org/drawingml/2006/main" id="48" idx="3"/>
+            <a:endCxn xmlns:a="http://schemas.openxmlformats.org/drawingml/2006/main" id="55" idx="1"/>
           </p:cNvCxnSpPr>
           <p:nvPr/>
         </p:nvCxnSpPr>
         <p:spPr>
           <a:xfrm xmlns:a="http://schemas.openxmlformats.org/drawingml/2006/main" flipV="1">
-            <a:off x="8286750" y="4552950"/>
-            <a:ext cx="762000" cy="292735"/>
+            <a:off x="7543800" y="4552950"/>
+            <a:ext cx="1504950" cy="250825"/>
           </a:xfrm>
           <a:prstGeom xmlns:a="http://schemas.openxmlformats.org/drawingml/2006/main" prst="bentConnector3">
             <a:avLst>
@@ -2844,7 +3916,7 @@
     </p:spTree>
     <p:extLst>
       <p:ext uri="{BB962C8B-B14F-4D97-AF65-F5344CB8AC3E}">
-        <p14:creationId xmlns:p14="http://schemas.microsoft.com/office/powerpoint/2010/main" val="1166040681"/>
+        <p14:creationId xmlns:p14="http://schemas.microsoft.com/office/powerpoint/2010/main" val="366154330"/>
       </p:ext>
     </p:extLst>
   </p:cSld>

</xml_diff>